<commit_message>
Close audit gaps: demo page (GitHub Pages), final video with recovery + benchmark, business value, throughput, README sections
Co-Authored-By: Claude Opus 5 <noreply@anthropic.com>
</commit_message>
<xml_diff>
--- a/submission/slides.pptx
+++ b/submission/slides.pptx
@@ -12,9 +12,10 @@
     <p:sldId id="260" r:id="rId6"/>
     <p:sldId id="261" r:id="rId7"/>
     <p:sldId id="262" r:id="rId8"/>
+    <p:sldId id="263" r:id="rId9"/>
   </p:sldIdLst>
   <p:notesMasterIdLst>
-    <p:notesMasterId r:id="rId9"/>
+    <p:notesMasterId r:id="rId10"/>
   </p:notesMasterIdLst>
   <p:sldSz cx="9144000" cy="5143500"/>
   <p:notesSz cx="5143500" cy="9144000"/>
@@ -1260,7 +1261,7 @@
           <a:p>
             <a:r>
               <a:rPr lang="en-US" dirty="0"/>
-              <a:t>Five steps, in a loop. The camera image is the only way the robot learns where things are. The vision-language model turns the command into goals, the planner decides who does what, the arms act, and after every item the robot looks again.</a:t>
+              <a:t>Why does this matter? Service robots in homes, hospitals, hotels and restaurants need exactly this combination: anyone can tell them what to do in plain language, they can use two hands, and they check their own work. And it's cheap: it runs on an ordinary laptop, and the skills teach themselves from demonstrations the robot records on its own.</a:t>
             </a:r>
             <a:endParaRPr lang="en-US" dirty="0"/>
           </a:p>
@@ -1348,7 +1349,7 @@
           <a:p>
             <a:r>
               <a:rPr lang="en-US" dirty="0"/>
-              <a:t>Cutlery often starts on the wrong arm's side, so the arms pass it across: one holds an end, the other takes the other end. And the robot checks its own work. Here we knock the plate out of place halfway through: it notices and fixes it before carrying on.</a:t>
+              <a:t>Five steps, in a loop. The camera image is the only way the robot learns where things are. The vision-language model turns the command into goals, the planner decides who does what, the arms act, and after every item the robot looks again.</a:t>
             </a:r>
             <a:endParaRPr lang="en-US" dirty="0"/>
           </a:p>
@@ -1436,7 +1437,7 @@
           <a:p>
             <a:r>
               <a:rPr lang="en-US" dirty="0"/>
-              <a:t>Instead of recording examples by hand, our scripted skills acted as the teacher and recorded over a thousand perfect demonstrations automatically, keeping only the successes. The first six versions failed, and each failure taught us something. Version seven places the mug correctly 95 percent of the time on tables it has never seen.</a:t>
+              <a:t>Cutlery often starts on the wrong arm's side, so the arms pass it across: one holds an end, the other takes the other end. And the robot checks its own work. Here we knock the plate out of place halfway through: it notices and fixes it before carrying on.</a:t>
             </a:r>
             <a:endParaRPr lang="en-US" dirty="0"/>
           </a:p>
@@ -1524,7 +1525,7 @@
           <a:p>
             <a:r>
               <a:rPr lang="en-US" dirty="0"/>
-              <a:t>OpenVINO makes our trained policy two and a half times faster on the laptop CPU, and the robot still succeeds just as often. For a model this small, INT8 and the integrated GPU don't pay off, and we say so. The vision-language model went from thirty seconds to four seconds per command, and the integrated GPU halves the time for large pictures.</a:t>
+              <a:t>Instead of recording examples by hand, our scripted skills acted as the teacher and recorded over a thousand perfect demonstrations automatically, keeping only the successes. The first six versions failed, and each failure taught us something. Version seven places the mug correctly 95 percent of the time on tables it has never seen.</a:t>
             </a:r>
             <a:endParaRPr lang="en-US" dirty="0"/>
           </a:p>
@@ -1612,7 +1613,7 @@
           <a:p>
             <a:r>
               <a:rPr lang="en-US" dirty="0"/>
-              <a:t>Everything is open source and seeded, so every number in this deck can be reproduced with one command. We're upfront about what's missing: a Core Ultra and NPU run, more learned skills, and the drawer and pouring. Thank you.</a:t>
+              <a:t>OpenVINO makes our trained policy two and a half times faster on the laptop CPU, and the robot still succeeds just as often. For a model this small, INT8 and the integrated GPU don't pay off, and we say so. The vision-language model went from thirty seconds to four seconds per command, and the integrated GPU halves the time for large pictures.</a:t>
             </a:r>
             <a:endParaRPr lang="en-US" dirty="0"/>
           </a:p>
@@ -1636,6 +1637,94 @@
             <a:fld id="{F7021451-1387-4CA6-816F-3879F97B5CBC}" type="slidenum">
               <a:rPr lang="en-US"/>
               <a:t>7</a:t>
+            </a:fld>
+            <a:endParaRPr lang="en-US"/>
+          </a:p>
+        </p:txBody>
+      </p:sp>
+    </p:spTree>
+    <p:extLst>
+      <p:ext uri="{BB962C8B-B14F-4D97-AF65-F5344CB8AC3E}">
+        <p14:creationId xmlns:p14="http://schemas.microsoft.com/office/powerpoint/2010/main" val="1024086991"/>
+      </p:ext>
+    </p:extLst>
+  </p:cSld>
+  <p:clrMapOvr>
+    <a:masterClrMapping/>
+  </p:clrMapOvr>
+</p:notes>
+</file>
+
+<file path=ppt/notesSlides/notesSlide8.xml><?xml version="1.0" encoding="utf-8"?>
+<p:notes xmlns:a="http://schemas.openxmlformats.org/drawingml/2006/main" xmlns:r="http://schemas.openxmlformats.org/officeDocument/2006/relationships" xmlns:p="http://schemas.openxmlformats.org/presentationml/2006/main">
+  <p:cSld>
+    <p:spTree>
+      <p:nvGrpSpPr>
+        <p:cNvPr id="1" name=""/>
+        <p:cNvGrpSpPr/>
+        <p:nvPr/>
+      </p:nvGrpSpPr>
+      <p:grpSpPr>
+        <a:xfrm>
+          <a:off x="0" y="0"/>
+          <a:ext cx="0" cy="0"/>
+          <a:chOff x="0" y="0"/>
+          <a:chExt cx="0" cy="0"/>
+        </a:xfrm>
+      </p:grpSpPr>
+      <p:sp>
+        <p:nvSpPr>
+          <p:cNvPr id="2" name="Slide Image Placeholder 1"/>
+          <p:cNvSpPr>
+            <a:spLocks noGrp="1" noRot="1" noChangeAspect="1"/>
+          </p:cNvSpPr>
+          <p:nvPr>
+            <p:ph type="sldImg"/>
+          </p:nvPr>
+        </p:nvSpPr>
+        <p:spPr/>
+      </p:sp>
+      <p:sp>
+        <p:nvSpPr>
+          <p:cNvPr id="3" name="Notes Placeholder 2"/>
+          <p:cNvSpPr>
+            <a:spLocks noGrp="1"/>
+          </p:cNvSpPr>
+          <p:nvPr>
+            <p:ph type="body" idx="1"/>
+          </p:nvPr>
+        </p:nvSpPr>
+        <p:spPr/>
+        <p:txBody>
+          <a:bodyPr/>
+          <a:lstStyle/>
+          <a:p>
+            <a:r>
+              <a:rPr lang="en-US" dirty="0"/>
+              <a:t>Everything is open source and seeded, so every number in this deck can be reproduced with one command. We're upfront about what's missing: a Core Ultra and NPU run, more learned skills, and the drawer and pouring. Thank you.</a:t>
+            </a:r>
+            <a:endParaRPr lang="en-US" dirty="0"/>
+          </a:p>
+        </p:txBody>
+      </p:sp>
+      <p:sp>
+        <p:nvSpPr>
+          <p:cNvPr id="4" name="Slide Number Placeholder 3"/>
+          <p:cNvSpPr>
+            <a:spLocks noGrp="1"/>
+          </p:cNvSpPr>
+          <p:nvPr>
+            <p:ph type="sldNum" sz="quarter" idx="10"/>
+          </p:nvPr>
+        </p:nvSpPr>
+        <p:spPr/>
+        <p:txBody>
+          <a:bodyPr/>
+          <a:lstStyle/>
+          <a:p>
+            <a:fld id="{F7021451-1387-4CA6-816F-3879F97B5CBC}" type="slidenum">
+              <a:rPr lang="en-US"/>
+              <a:t>8</a:t>
             </a:fld>
             <a:endParaRPr lang="en-US"/>
           </a:p>
@@ -2191,7 +2280,7 @@
                 <a:ea typeface="Calibri" pitchFamily="34" charset="-122"/>
                 <a:cs typeface="Calibri" pitchFamily="34" charset="-120"/>
               </a:rPr>
-              <a:t>Say or type what you want</a:t>
+              <a:t>Type what you want</a:t>
             </a:r>
             <a:endParaRPr lang="en-US" sz="1600" dirty="0"/>
           </a:p>
@@ -2750,7 +2839,7 @@
                 <a:ea typeface="Arial" pitchFamily="34" charset="-122"/>
                 <a:cs typeface="Arial" pitchFamily="34" charset="-120"/>
               </a:rPr>
-              <a:t>Observe, understand, plan, act, look again</a:t>
+              <a:t>Why it matters</a:t>
             </a:r>
             <a:endParaRPr lang="en-US" sz="3000" dirty="0"/>
           </a:p>
@@ -2758,14 +2847,80 @@
       </p:sp>
       <p:sp>
         <p:nvSpPr>
-          <p:cNvPr id="3" name="Shape 1"/>
+          <p:cNvPr id="3" name="Text 1"/>
+          <p:cNvSpPr txBox="1"/>
+          <p:nvPr/>
+        </p:nvSpPr>
+        <p:spPr>
+          <a:xfrm>
+            <a:off x="457200" y="804672"/>
+            <a:ext cx="8229600" cy="320040"/>
+          </a:xfrm>
+          <a:prstGeom prst="rect">
+            <a:avLst/>
+          </a:prstGeom>
+          <a:noFill/>
+          <a:ln/>
+        </p:spPr>
+        <p:txBody>
+          <a:bodyPr wrap="square" lIns="0" tIns="0" rIns="0" bIns="0" rtlCol="0" anchor="ctr"/>
+          <a:lstStyle/>
+          <a:p>
+            <a:pPr indent="0" marL="0">
+              <a:buNone/>
+            </a:pPr>
+            <a:r>
+              <a:rPr lang="en-US" sz="1400" dirty="0">
+                <a:solidFill>
+                  <a:srgbClr val="9AA7B5"/>
+                </a:solidFill>
+                <a:latin typeface="Calibri" pitchFamily="34" charset="0"/>
+                <a:ea typeface="Calibri" pitchFamily="34" charset="-122"/>
+                <a:cs typeface="Calibri" pitchFamily="34" charset="-120"/>
+              </a:rPr>
+              <a:t>Service robots for homes, hospitals, hotels and restaurants</a:t>
+            </a:r>
+            <a:endParaRPr lang="en-US" sz="1400" dirty="0"/>
+          </a:p>
+        </p:txBody>
+      </p:sp>
+      <p:sp>
+        <p:nvSpPr>
+          <p:cNvPr id="4" name="Shape 2"/>
           <p:cNvSpPr/>
           <p:nvPr/>
         </p:nvSpPr>
         <p:spPr>
           <a:xfrm>
-            <a:off x="457200" y="1143000"/>
-            <a:ext cx="384048" cy="384048"/>
+            <a:off x="457200" y="1325880"/>
+            <a:ext cx="4023360" cy="1600200"/>
+          </a:xfrm>
+          <a:prstGeom prst="roundRect">
+            <a:avLst>
+              <a:gd name="adj" fmla="val 4571"/>
+            </a:avLst>
+          </a:prstGeom>
+          <a:solidFill>
+            <a:srgbClr val="222A35"/>
+          </a:solidFill>
+          <a:ln w="12700">
+            <a:solidFill>
+              <a:srgbClr val="222A35"/>
+            </a:solidFill>
+            <a:prstDash val="solid"/>
+          </a:ln>
+        </p:spPr>
+      </p:sp>
+      <p:sp>
+        <p:nvSpPr>
+          <p:cNvPr id="5" name="Shape 3"/>
+          <p:cNvSpPr/>
+          <p:nvPr/>
+        </p:nvSpPr>
+        <p:spPr>
+          <a:xfrm>
+            <a:off x="685800" y="1581912"/>
+            <a:ext cx="365760" cy="365760"/>
           </a:xfrm>
           <a:prstGeom prst="ellipse">
             <a:avLst/>
@@ -2783,14 +2938,14 @@
       </p:sp>
       <p:sp>
         <p:nvSpPr>
-          <p:cNvPr id="4" name="Text 2"/>
-          <p:cNvSpPr txBox="1"/>
-          <p:nvPr/>
-        </p:nvSpPr>
-        <p:spPr>
-          <a:xfrm>
-            <a:off x="457200" y="1143000"/>
-            <a:ext cx="384048" cy="384048"/>
+          <p:cNvPr id="6" name="Text 4"/>
+          <p:cNvSpPr txBox="1"/>
+          <p:nvPr/>
+        </p:nvSpPr>
+        <p:spPr>
+          <a:xfrm>
+            <a:off x="685800" y="1581912"/>
+            <a:ext cx="365760" cy="365760"/>
           </a:xfrm>
           <a:prstGeom prst="rect">
             <a:avLst/>
@@ -2822,14 +2977,14 @@
       </p:sp>
       <p:sp>
         <p:nvSpPr>
-          <p:cNvPr id="5" name="Text 3"/>
-          <p:cNvSpPr txBox="1"/>
-          <p:nvPr/>
-        </p:nvSpPr>
-        <p:spPr>
-          <a:xfrm>
-            <a:off x="457200" y="1627632"/>
-            <a:ext cx="1554480" cy="320040"/>
+          <p:cNvPr id="7" name="Text 5"/>
+          <p:cNvSpPr txBox="1"/>
+          <p:nvPr/>
+        </p:nvSpPr>
+        <p:spPr>
+          <a:xfrm>
+            <a:off x="1188720" y="1581912"/>
+            <a:ext cx="3108960" cy="365760"/>
           </a:xfrm>
           <a:prstGeom prst="rect">
             <a:avLst/>
@@ -2845,7 +3000,7 @@
               <a:buNone/>
             </a:pPr>
             <a:r>
-              <a:rPr lang="en-US" sz="1500" b="1" dirty="0">
+              <a:rPr lang="en-US" sz="1600" b="1" dirty="0">
                 <a:solidFill>
                   <a:srgbClr val="FFFFFF"/>
                 </a:solidFill>
@@ -2853,22 +3008,22 @@
                 <a:ea typeface="Arial" pitchFamily="34" charset="-122"/>
                 <a:cs typeface="Arial" pitchFamily="34" charset="-120"/>
               </a:rPr>
-              <a:t>Observe</a:t>
-            </a:r>
-            <a:endParaRPr lang="en-US" sz="1500" dirty="0"/>
-          </a:p>
-        </p:txBody>
-      </p:sp>
-      <p:sp>
-        <p:nvSpPr>
-          <p:cNvPr id="6" name="Text 4"/>
-          <p:cNvSpPr txBox="1"/>
-          <p:nvPr/>
-        </p:nvSpPr>
-        <p:spPr>
-          <a:xfrm>
-            <a:off x="457200" y="1938528"/>
-            <a:ext cx="1508760" cy="822960"/>
+              <a:t>Anyone can instruct it</a:t>
+            </a:r>
+            <a:endParaRPr lang="en-US" sz="1600" dirty="0"/>
+          </a:p>
+        </p:txBody>
+      </p:sp>
+      <p:sp>
+        <p:nvSpPr>
+          <p:cNvPr id="8" name="Text 6"/>
+          <p:cNvSpPr txBox="1"/>
+          <p:nvPr/>
+        </p:nvSpPr>
+        <p:spPr>
+          <a:xfrm>
+            <a:off x="1188720" y="1984248"/>
+            <a:ext cx="3108960" cy="822960"/>
           </a:xfrm>
           <a:prstGeom prst="rect">
             <a:avLst/>
@@ -2884,7 +3039,7 @@
               <a:buNone/>
             </a:pPr>
             <a:r>
-              <a:rPr lang="en-US" sz="1200" dirty="0">
+              <a:rPr lang="en-US" sz="1300" dirty="0">
                 <a:solidFill>
                   <a:srgbClr val="9AA7B5"/>
                 </a:solidFill>
@@ -2892,22 +3047,49 @@
                 <a:ea typeface="Calibri" pitchFamily="34" charset="-122"/>
                 <a:cs typeface="Calibri" pitchFamily="34" charset="-120"/>
               </a:rPr>
-              <a:t>overhead colour + depth camera finds every object</a:t>
-            </a:r>
-            <a:endParaRPr lang="en-US" sz="1200" dirty="0"/>
-          </a:p>
-        </p:txBody>
-      </p:sp>
-      <p:sp>
-        <p:nvSpPr>
-          <p:cNvPr id="7" name="Shape 5"/>
+              <a:t>Plain-language instructions. No programming, no app, no fixed commands.</a:t>
+            </a:r>
+            <a:endParaRPr lang="en-US" sz="1300" dirty="0"/>
+          </a:p>
+        </p:txBody>
+      </p:sp>
+      <p:sp>
+        <p:nvSpPr>
+          <p:cNvPr id="9" name="Shape 7"/>
           <p:cNvSpPr/>
           <p:nvPr/>
         </p:nvSpPr>
         <p:spPr>
           <a:xfrm>
-            <a:off x="2121408" y="1143000"/>
-            <a:ext cx="384048" cy="384048"/>
+            <a:off x="4663440" y="1325880"/>
+            <a:ext cx="4023360" cy="1600200"/>
+          </a:xfrm>
+          <a:prstGeom prst="roundRect">
+            <a:avLst>
+              <a:gd name="adj" fmla="val 4571"/>
+            </a:avLst>
+          </a:prstGeom>
+          <a:solidFill>
+            <a:srgbClr val="222A35"/>
+          </a:solidFill>
+          <a:ln w="12700">
+            <a:solidFill>
+              <a:srgbClr val="222A35"/>
+            </a:solidFill>
+            <a:prstDash val="solid"/>
+          </a:ln>
+        </p:spPr>
+      </p:sp>
+      <p:sp>
+        <p:nvSpPr>
+          <p:cNvPr id="10" name="Shape 8"/>
+          <p:cNvSpPr/>
+          <p:nvPr/>
+        </p:nvSpPr>
+        <p:spPr>
+          <a:xfrm>
+            <a:off x="4892040" y="1581912"/>
+            <a:ext cx="365760" cy="365760"/>
           </a:xfrm>
           <a:prstGeom prst="ellipse">
             <a:avLst/>
@@ -2925,14 +3107,14 @@
       </p:sp>
       <p:sp>
         <p:nvSpPr>
-          <p:cNvPr id="8" name="Text 6"/>
-          <p:cNvSpPr txBox="1"/>
-          <p:nvPr/>
-        </p:nvSpPr>
-        <p:spPr>
-          <a:xfrm>
-            <a:off x="2121408" y="1143000"/>
-            <a:ext cx="384048" cy="384048"/>
+          <p:cNvPr id="11" name="Text 9"/>
+          <p:cNvSpPr txBox="1"/>
+          <p:nvPr/>
+        </p:nvSpPr>
+        <p:spPr>
+          <a:xfrm>
+            <a:off x="4892040" y="1581912"/>
+            <a:ext cx="365760" cy="365760"/>
           </a:xfrm>
           <a:prstGeom prst="rect">
             <a:avLst/>
@@ -2964,14 +3146,14 @@
       </p:sp>
       <p:sp>
         <p:nvSpPr>
-          <p:cNvPr id="9" name="Text 7"/>
-          <p:cNvSpPr txBox="1"/>
-          <p:nvPr/>
-        </p:nvSpPr>
-        <p:spPr>
-          <a:xfrm>
-            <a:off x="2121408" y="1627632"/>
-            <a:ext cx="1554480" cy="320040"/>
+          <p:cNvPr id="12" name="Text 10"/>
+          <p:cNvSpPr txBox="1"/>
+          <p:nvPr/>
+        </p:nvSpPr>
+        <p:spPr>
+          <a:xfrm>
+            <a:off x="5394960" y="1581912"/>
+            <a:ext cx="3108960" cy="365760"/>
           </a:xfrm>
           <a:prstGeom prst="rect">
             <a:avLst/>
@@ -2987,7 +3169,7 @@
               <a:buNone/>
             </a:pPr>
             <a:r>
-              <a:rPr lang="en-US" sz="1500" b="1" dirty="0">
+              <a:rPr lang="en-US" sz="1600" b="1" dirty="0">
                 <a:solidFill>
                   <a:srgbClr val="FFFFFF"/>
                 </a:solidFill>
@@ -2995,22 +3177,22 @@
                 <a:ea typeface="Arial" pitchFamily="34" charset="-122"/>
                 <a:cs typeface="Arial" pitchFamily="34" charset="-120"/>
               </a:rPr>
-              <a:t>Understand</a:t>
-            </a:r>
-            <a:endParaRPr lang="en-US" sz="1500" dirty="0"/>
-          </a:p>
-        </p:txBody>
-      </p:sp>
-      <p:sp>
-        <p:nvSpPr>
-          <p:cNvPr id="10" name="Text 8"/>
-          <p:cNvSpPr txBox="1"/>
-          <p:nvPr/>
-        </p:nvSpPr>
-        <p:spPr>
-          <a:xfrm>
-            <a:off x="2121408" y="1938528"/>
-            <a:ext cx="1508760" cy="822960"/>
+              <a:t>Two hands, real tasks</a:t>
+            </a:r>
+            <a:endParaRPr lang="en-US" sz="1600" dirty="0"/>
+          </a:p>
+        </p:txBody>
+      </p:sp>
+      <p:sp>
+        <p:nvSpPr>
+          <p:cNvPr id="13" name="Text 11"/>
+          <p:cNvSpPr txBox="1"/>
+          <p:nvPr/>
+        </p:nvSpPr>
+        <p:spPr>
+          <a:xfrm>
+            <a:off x="5394960" y="1984248"/>
+            <a:ext cx="3108960" cy="822960"/>
           </a:xfrm>
           <a:prstGeom prst="rect">
             <a:avLst/>
@@ -3026,7 +3208,7 @@
               <a:buNone/>
             </a:pPr>
             <a:r>
-              <a:rPr lang="en-US" sz="1200" dirty="0">
+              <a:rPr lang="en-US" sz="1300" dirty="0">
                 <a:solidFill>
                   <a:srgbClr val="9AA7B5"/>
                 </a:solidFill>
@@ -3034,22 +3216,49 @@
                 <a:ea typeface="Calibri" pitchFamily="34" charset="-122"/>
                 <a:cs typeface="Calibri" pitchFamily="34" charset="-120"/>
               </a:rPr>
-              <a:t>Qwen3-VL-4B on OpenVINO reads the command and the picture</a:t>
-            </a:r>
-            <a:endParaRPr lang="en-US" sz="1200" dirty="0"/>
-          </a:p>
-        </p:txBody>
-      </p:sp>
-      <p:sp>
-        <p:nvSpPr>
-          <p:cNvPr id="11" name="Shape 9"/>
+              <a:t>Passing, holding and placing — the everyday handling that one-armed robots can't do.</a:t>
+            </a:r>
+            <a:endParaRPr lang="en-US" sz="1300" dirty="0"/>
+          </a:p>
+        </p:txBody>
+      </p:sp>
+      <p:sp>
+        <p:nvSpPr>
+          <p:cNvPr id="14" name="Shape 12"/>
           <p:cNvSpPr/>
           <p:nvPr/>
         </p:nvSpPr>
         <p:spPr>
           <a:xfrm>
-            <a:off x="3785616" y="1143000"/>
-            <a:ext cx="384048" cy="384048"/>
+            <a:off x="457200" y="3108960"/>
+            <a:ext cx="4023360" cy="1600200"/>
+          </a:xfrm>
+          <a:prstGeom prst="roundRect">
+            <a:avLst>
+              <a:gd name="adj" fmla="val 4571"/>
+            </a:avLst>
+          </a:prstGeom>
+          <a:solidFill>
+            <a:srgbClr val="222A35"/>
+          </a:solidFill>
+          <a:ln w="12700">
+            <a:solidFill>
+              <a:srgbClr val="222A35"/>
+            </a:solidFill>
+            <a:prstDash val="solid"/>
+          </a:ln>
+        </p:spPr>
+      </p:sp>
+      <p:sp>
+        <p:nvSpPr>
+          <p:cNvPr id="15" name="Shape 13"/>
+          <p:cNvSpPr/>
+          <p:nvPr/>
+        </p:nvSpPr>
+        <p:spPr>
+          <a:xfrm>
+            <a:off x="685800" y="3364992"/>
+            <a:ext cx="365760" cy="365760"/>
           </a:xfrm>
           <a:prstGeom prst="ellipse">
             <a:avLst/>
@@ -3067,14 +3276,14 @@
       </p:sp>
       <p:sp>
         <p:nvSpPr>
-          <p:cNvPr id="12" name="Text 10"/>
-          <p:cNvSpPr txBox="1"/>
-          <p:nvPr/>
-        </p:nvSpPr>
-        <p:spPr>
-          <a:xfrm>
-            <a:off x="3785616" y="1143000"/>
-            <a:ext cx="384048" cy="384048"/>
+          <p:cNvPr id="16" name="Text 14"/>
+          <p:cNvSpPr txBox="1"/>
+          <p:nvPr/>
+        </p:nvSpPr>
+        <p:spPr>
+          <a:xfrm>
+            <a:off x="685800" y="3364992"/>
+            <a:ext cx="365760" cy="365760"/>
           </a:xfrm>
           <a:prstGeom prst="rect">
             <a:avLst/>
@@ -3106,14 +3315,14 @@
       </p:sp>
       <p:sp>
         <p:nvSpPr>
-          <p:cNvPr id="13" name="Text 11"/>
-          <p:cNvSpPr txBox="1"/>
-          <p:nvPr/>
-        </p:nvSpPr>
-        <p:spPr>
-          <a:xfrm>
-            <a:off x="3785616" y="1627632"/>
-            <a:ext cx="1554480" cy="320040"/>
+          <p:cNvPr id="17" name="Text 15"/>
+          <p:cNvSpPr txBox="1"/>
+          <p:nvPr/>
+        </p:nvSpPr>
+        <p:spPr>
+          <a:xfrm>
+            <a:off x="1188720" y="3364992"/>
+            <a:ext cx="3108960" cy="365760"/>
           </a:xfrm>
           <a:prstGeom prst="rect">
             <a:avLst/>
@@ -3129,7 +3338,7 @@
               <a:buNone/>
             </a:pPr>
             <a:r>
-              <a:rPr lang="en-US" sz="1500" b="1" dirty="0">
+              <a:rPr lang="en-US" sz="1600" b="1" dirty="0">
                 <a:solidFill>
                   <a:srgbClr val="FFFFFF"/>
                 </a:solidFill>
@@ -3137,22 +3346,22 @@
                 <a:ea typeface="Arial" pitchFamily="34" charset="-122"/>
                 <a:cs typeface="Arial" pitchFamily="34" charset="-120"/>
               </a:rPr>
-              <a:t>Plan</a:t>
-            </a:r>
-            <a:endParaRPr lang="en-US" sz="1500" dirty="0"/>
-          </a:p>
-        </p:txBody>
-      </p:sp>
-      <p:sp>
-        <p:nvSpPr>
-          <p:cNvPr id="14" name="Text 12"/>
-          <p:cNvSpPr txBox="1"/>
-          <p:nvPr/>
-        </p:nvSpPr>
-        <p:spPr>
-          <a:xfrm>
-            <a:off x="3785616" y="1938528"/>
-            <a:ext cx="1508760" cy="822960"/>
+              <a:t>Checks its own work</a:t>
+            </a:r>
+            <a:endParaRPr lang="en-US" sz="1600" dirty="0"/>
+          </a:p>
+        </p:txBody>
+      </p:sp>
+      <p:sp>
+        <p:nvSpPr>
+          <p:cNvPr id="18" name="Text 16"/>
+          <p:cNvSpPr txBox="1"/>
+          <p:nvPr/>
+        </p:nvSpPr>
+        <p:spPr>
+          <a:xfrm>
+            <a:off x="1188720" y="3767328"/>
+            <a:ext cx="3108960" cy="822960"/>
           </a:xfrm>
           <a:prstGeom prst="rect">
             <a:avLst/>
@@ -3168,7 +3377,7 @@
               <a:buNone/>
             </a:pPr>
             <a:r>
-              <a:rPr lang="en-US" sz="1200" dirty="0">
+              <a:rPr lang="en-US" sz="1300" dirty="0">
                 <a:solidFill>
                   <a:srgbClr val="9AA7B5"/>
                 </a:solidFill>
@@ -3176,22 +3385,49 @@
                 <a:ea typeface="Calibri" pitchFamily="34" charset="-122"/>
                 <a:cs typeface="Calibri" pitchFamily="34" charset="-120"/>
               </a:rPr>
-              <a:t>which arm, hand-off or set-down swap, what first</a:t>
-            </a:r>
-            <a:endParaRPr lang="en-US" sz="1200" dirty="0"/>
-          </a:p>
-        </p:txBody>
-      </p:sp>
-      <p:sp>
-        <p:nvSpPr>
-          <p:cNvPr id="15" name="Shape 13"/>
+              <a:t>A bump or a slip is noticed and fixed, so a job gets finished without a person watching.</a:t>
+            </a:r>
+            <a:endParaRPr lang="en-US" sz="1300" dirty="0"/>
+          </a:p>
+        </p:txBody>
+      </p:sp>
+      <p:sp>
+        <p:nvSpPr>
+          <p:cNvPr id="19" name="Shape 17"/>
           <p:cNvSpPr/>
           <p:nvPr/>
         </p:nvSpPr>
         <p:spPr>
           <a:xfrm>
-            <a:off x="5449824" y="1143000"/>
-            <a:ext cx="384048" cy="384048"/>
+            <a:off x="4663440" y="3108960"/>
+            <a:ext cx="4023360" cy="1600200"/>
+          </a:xfrm>
+          <a:prstGeom prst="roundRect">
+            <a:avLst>
+              <a:gd name="adj" fmla="val 4571"/>
+            </a:avLst>
+          </a:prstGeom>
+          <a:solidFill>
+            <a:srgbClr val="222A35"/>
+          </a:solidFill>
+          <a:ln w="12700">
+            <a:solidFill>
+              <a:srgbClr val="222A35"/>
+            </a:solidFill>
+            <a:prstDash val="solid"/>
+          </a:ln>
+        </p:spPr>
+      </p:sp>
+      <p:sp>
+        <p:nvSpPr>
+          <p:cNvPr id="20" name="Shape 18"/>
+          <p:cNvSpPr/>
+          <p:nvPr/>
+        </p:nvSpPr>
+        <p:spPr>
+          <a:xfrm>
+            <a:off x="4892040" y="3364992"/>
+            <a:ext cx="365760" cy="365760"/>
           </a:xfrm>
           <a:prstGeom prst="ellipse">
             <a:avLst/>
@@ -3209,14 +3445,14 @@
       </p:sp>
       <p:sp>
         <p:nvSpPr>
-          <p:cNvPr id="16" name="Text 14"/>
-          <p:cNvSpPr txBox="1"/>
-          <p:nvPr/>
-        </p:nvSpPr>
-        <p:spPr>
-          <a:xfrm>
-            <a:off x="5449824" y="1143000"/>
-            <a:ext cx="384048" cy="384048"/>
+          <p:cNvPr id="21" name="Text 19"/>
+          <p:cNvSpPr txBox="1"/>
+          <p:nvPr/>
+        </p:nvSpPr>
+        <p:spPr>
+          <a:xfrm>
+            <a:off x="4892040" y="3364992"/>
+            <a:ext cx="365760" cy="365760"/>
           </a:xfrm>
           <a:prstGeom prst="rect">
             <a:avLst/>
@@ -3248,14 +3484,14 @@
       </p:sp>
       <p:sp>
         <p:nvSpPr>
-          <p:cNvPr id="17" name="Text 15"/>
-          <p:cNvSpPr txBox="1"/>
-          <p:nvPr/>
-        </p:nvSpPr>
-        <p:spPr>
-          <a:xfrm>
-            <a:off x="5449824" y="1627632"/>
-            <a:ext cx="1554480" cy="320040"/>
+          <p:cNvPr id="22" name="Text 20"/>
+          <p:cNvSpPr txBox="1"/>
+          <p:nvPr/>
+        </p:nvSpPr>
+        <p:spPr>
+          <a:xfrm>
+            <a:off x="5394960" y="3364992"/>
+            <a:ext cx="3108960" cy="365760"/>
           </a:xfrm>
           <a:prstGeom prst="rect">
             <a:avLst/>
@@ -3271,7 +3507,7 @@
               <a:buNone/>
             </a:pPr>
             <a:r>
-              <a:rPr lang="en-US" sz="1500" b="1" dirty="0">
+              <a:rPr lang="en-US" sz="1600" b="1" dirty="0">
                 <a:solidFill>
                   <a:srgbClr val="FFFFFF"/>
                 </a:solidFill>
@@ -3279,22 +3515,22 @@
                 <a:ea typeface="Arial" pitchFamily="34" charset="-122"/>
                 <a:cs typeface="Arial" pitchFamily="34" charset="-120"/>
               </a:rPr>
-              <a:t>Act</a:t>
-            </a:r>
-            <a:endParaRPr lang="en-US" sz="1500" dirty="0"/>
-          </a:p>
-        </p:txBody>
-      </p:sp>
-      <p:sp>
-        <p:nvSpPr>
-          <p:cNvPr id="18" name="Text 16"/>
-          <p:cNvSpPr txBox="1"/>
-          <p:nvPr/>
-        </p:nvSpPr>
-        <p:spPr>
-          <a:xfrm>
-            <a:off x="5449824" y="1938528"/>
-            <a:ext cx="1508760" cy="822960"/>
+              <a:t>Cheap to run and to teach</a:t>
+            </a:r>
+            <a:endParaRPr lang="en-US" sz="1600" dirty="0"/>
+          </a:p>
+        </p:txBody>
+      </p:sp>
+      <p:sp>
+        <p:nvSpPr>
+          <p:cNvPr id="23" name="Text 21"/>
+          <p:cNvSpPr txBox="1"/>
+          <p:nvPr/>
+        </p:nvSpPr>
+        <p:spPr>
+          <a:xfrm>
+            <a:off x="5394960" y="3767328"/>
+            <a:ext cx="3108960" cy="822960"/>
           </a:xfrm>
           <a:prstGeom prst="rect">
             <a:avLst/>
@@ -3310,7 +3546,7 @@
               <a:buNone/>
             </a:pPr>
             <a:r>
-              <a:rPr lang="en-US" sz="1200" dirty="0">
+              <a:rPr lang="en-US" sz="1300" dirty="0">
                 <a:solidFill>
                   <a:srgbClr val="9AA7B5"/>
                 </a:solidFill>
@@ -3318,265 +3554,9 @@
                 <a:ea typeface="Calibri" pitchFamily="34" charset="-122"/>
                 <a:cs typeface="Calibri" pitchFamily="34" charset="-120"/>
               </a:rPr>
-              <a:t>two SO-101 arms; a trained ACT policy for the mug</a:t>
-            </a:r>
-            <a:endParaRPr lang="en-US" sz="1200" dirty="0"/>
-          </a:p>
-        </p:txBody>
-      </p:sp>
-      <p:sp>
-        <p:nvSpPr>
-          <p:cNvPr id="19" name="Shape 17"/>
-          <p:cNvSpPr/>
-          <p:nvPr/>
-        </p:nvSpPr>
-        <p:spPr>
-          <a:xfrm>
-            <a:off x="7114032" y="1143000"/>
-            <a:ext cx="384048" cy="384048"/>
-          </a:xfrm>
-          <a:prstGeom prst="ellipse">
-            <a:avLst/>
-          </a:prstGeom>
-          <a:solidFill>
-            <a:srgbClr val="E8B923"/>
-          </a:solidFill>
-          <a:ln w="12700">
-            <a:solidFill>
-              <a:srgbClr val="E8B923"/>
-            </a:solidFill>
-            <a:prstDash val="solid"/>
-          </a:ln>
-        </p:spPr>
-      </p:sp>
-      <p:sp>
-        <p:nvSpPr>
-          <p:cNvPr id="20" name="Text 18"/>
-          <p:cNvSpPr txBox="1"/>
-          <p:nvPr/>
-        </p:nvSpPr>
-        <p:spPr>
-          <a:xfrm>
-            <a:off x="7114032" y="1143000"/>
-            <a:ext cx="384048" cy="384048"/>
-          </a:xfrm>
-          <a:prstGeom prst="rect">
-            <a:avLst/>
-          </a:prstGeom>
-          <a:noFill/>
-          <a:ln/>
-        </p:spPr>
-        <p:txBody>
-          <a:bodyPr wrap="square" lIns="0" tIns="0" rIns="0" bIns="0" rtlCol="0" anchor="ctr"/>
-          <a:lstStyle/>
-          <a:p>
-            <a:pPr algn="ctr" indent="0" marL="0">
-              <a:buNone/>
-            </a:pPr>
-            <a:r>
-              <a:rPr lang="en-US" sz="1400" b="1" dirty="0">
-                <a:solidFill>
-                  <a:srgbClr val="161B22"/>
-                </a:solidFill>
-                <a:latin typeface="Arial" pitchFamily="34" charset="0"/>
-                <a:ea typeface="Arial" pitchFamily="34" charset="-122"/>
-                <a:cs typeface="Arial" pitchFamily="34" charset="-120"/>
-              </a:rPr>
-              <a:t>5</a:t>
-            </a:r>
-            <a:endParaRPr lang="en-US" sz="1400" dirty="0"/>
-          </a:p>
-        </p:txBody>
-      </p:sp>
-      <p:sp>
-        <p:nvSpPr>
-          <p:cNvPr id="21" name="Text 19"/>
-          <p:cNvSpPr txBox="1"/>
-          <p:nvPr/>
-        </p:nvSpPr>
-        <p:spPr>
-          <a:xfrm>
-            <a:off x="7114032" y="1627632"/>
-            <a:ext cx="1554480" cy="320040"/>
-          </a:xfrm>
-          <a:prstGeom prst="rect">
-            <a:avLst/>
-          </a:prstGeom>
-          <a:noFill/>
-          <a:ln/>
-        </p:spPr>
-        <p:txBody>
-          <a:bodyPr wrap="square" lIns="0" tIns="0" rIns="0" bIns="0" rtlCol="0" anchor="ctr"/>
-          <a:lstStyle/>
-          <a:p>
-            <a:pPr indent="0" marL="0">
-              <a:buNone/>
-            </a:pPr>
-            <a:r>
-              <a:rPr lang="en-US" sz="1500" b="1" dirty="0">
-                <a:solidFill>
-                  <a:srgbClr val="FFFFFF"/>
-                </a:solidFill>
-                <a:latin typeface="Arial" pitchFamily="34" charset="0"/>
-                <a:ea typeface="Arial" pitchFamily="34" charset="-122"/>
-                <a:cs typeface="Arial" pitchFamily="34" charset="-120"/>
-              </a:rPr>
-              <a:t>Look again</a:t>
-            </a:r>
-            <a:endParaRPr lang="en-US" sz="1500" dirty="0"/>
-          </a:p>
-        </p:txBody>
-      </p:sp>
-      <p:sp>
-        <p:nvSpPr>
-          <p:cNvPr id="22" name="Text 20"/>
-          <p:cNvSpPr txBox="1"/>
-          <p:nvPr/>
-        </p:nvSpPr>
-        <p:spPr>
-          <a:xfrm>
-            <a:off x="7114032" y="1938528"/>
-            <a:ext cx="1508760" cy="822960"/>
-          </a:xfrm>
-          <a:prstGeom prst="rect">
-            <a:avLst/>
-          </a:prstGeom>
-          <a:noFill/>
-          <a:ln/>
-        </p:spPr>
-        <p:txBody>
-          <a:bodyPr wrap="square" lIns="0" tIns="0" rIns="0" bIns="0" rtlCol="0" anchor="t"/>
-          <a:lstStyle/>
-          <a:p>
-            <a:pPr indent="0" marL="0">
-              <a:buNone/>
-            </a:pPr>
-            <a:r>
-              <a:rPr lang="en-US" sz="1200" dirty="0">
-                <a:solidFill>
-                  <a:srgbClr val="9AA7B5"/>
-                </a:solidFill>
-                <a:latin typeface="Calibri" pitchFamily="34" charset="0"/>
-                <a:ea typeface="Calibri" pitchFamily="34" charset="-122"/>
-                <a:cs typeface="Calibri" pitchFamily="34" charset="-120"/>
-              </a:rPr>
-              <a:t>anything knocked out of place is fixed first</a:t>
-            </a:r>
-            <a:endParaRPr lang="en-US" sz="1200" dirty="0"/>
-          </a:p>
-        </p:txBody>
-      </p:sp>
-      <p:pic>
-        <p:nvPicPr>
-          <p:cNvPr id="23" name="Image 0" descr="C:\DriveSync\Creative\hackathons\ai-infra-summit-2026\submission\img\eyes.png">    </p:cNvPr>
-          <p:cNvPicPr>
-            <a:picLocks noChangeAspect="1"/>
-          </p:cNvPicPr>
-          <p:nvPr/>
-        </p:nvPicPr>
-        <p:blipFill>
-          <a:blip r:embed="rId1"/>
-          <a:stretch>
-            <a:fillRect/>
-          </a:stretch>
-        </p:blipFill>
-        <p:spPr>
-          <a:xfrm>
-            <a:off x="457200" y="2926080"/>
-            <a:ext cx="2560320" cy="1920240"/>
-          </a:xfrm>
-          <a:prstGeom prst="rect">
-            <a:avLst/>
-          </a:prstGeom>
-        </p:spPr>
-      </p:pic>
-      <p:sp>
-        <p:nvSpPr>
-          <p:cNvPr id="24" name="Text 21"/>
-          <p:cNvSpPr txBox="1"/>
-          <p:nvPr/>
-        </p:nvSpPr>
-        <p:spPr>
-          <a:xfrm>
-            <a:off x="3291840" y="2971800"/>
-            <a:ext cx="5394960" cy="1828800"/>
-          </a:xfrm>
-          <a:prstGeom prst="rect">
-            <a:avLst/>
-          </a:prstGeom>
-          <a:noFill/>
-          <a:ln/>
-        </p:spPr>
-        <p:txBody>
-          <a:bodyPr wrap="square" lIns="0" tIns="0" rIns="0" bIns="0" rtlCol="0" anchor="t"/>
-          <a:lstStyle/>
-          <a:p>
-            <a:pPr indent="0" marL="0">
-              <a:buNone/>
-            </a:pPr>
-            <a:r>
-              <a:rPr lang="en-US" sz="1600" b="1" dirty="0">
-                <a:solidFill>
-                  <a:srgbClr val="FFFFFF"/>
-                </a:solidFill>
-                <a:latin typeface="Calibri" pitchFamily="34" charset="0"/>
-                <a:ea typeface="Calibri" pitchFamily="34" charset="-122"/>
-                <a:cs typeface="Calibri" pitchFamily="34" charset="-120"/>
-              </a:rPr>
-              <a:t>What the robot sees</a:t>
-            </a:r>
-            <a:endParaRPr lang="en-US" sz="1600" dirty="0"/>
-          </a:p>
-          <a:p>
-            <a:pPr indent="0" marL="0">
-              <a:buNone/>
-            </a:pPr>
-            <a:r>
-              <a:rPr lang="en-US" sz="1300" dirty="0">
-                <a:solidFill>
-                  <a:srgbClr val="9AA7B5"/>
-                </a:solidFill>
-                <a:latin typeface="Calibri" pitchFamily="34" charset="0"/>
-                <a:ea typeface="Calibri" pitchFamily="34" charset="-122"/>
-                <a:cs typeface="Calibri" pitchFamily="34" charset="-120"/>
-              </a:rPr>
-              <a:t>Objects are found from the height map and their shape, never from the simulator. On 20 random tables every object was found, 0.5 mm average error.</a:t>
-            </a:r>
-            <a:endParaRPr lang="en-US" sz="1600" dirty="0"/>
-          </a:p>
-          <a:p>
-            <a:pPr indent="0" marL="0">
-              <a:buNone/>
-            </a:pPr>
-            <a:r>
-              <a:rPr lang="en-US" sz="800" dirty="0">
-                <a:solidFill>
-                  <a:srgbClr val="000000"/>
-                </a:solidFill>
-                <a:latin typeface="Calibri" pitchFamily="34" charset="0"/>
-                <a:ea typeface="Calibri" pitchFamily="34" charset="-122"/>
-                <a:cs typeface="Calibri" pitchFamily="34" charset="-120"/>
-              </a:rPr>
-              <a:t> </a:t>
-            </a:r>
-            <a:endParaRPr lang="en-US" sz="1600" dirty="0"/>
-          </a:p>
-          <a:p>
-            <a:pPr indent="0" marL="0">
-              <a:buNone/>
-            </a:pPr>
-            <a:r>
-              <a:rPr lang="en-US" sz="1300" dirty="0">
-                <a:solidFill>
-                  <a:srgbClr val="9AA7B5"/>
-                </a:solidFill>
-                <a:latin typeface="Calibri" pitchFamily="34" charset="0"/>
-                <a:ea typeface="Calibri" pitchFamily="34" charset="-122"/>
-                <a:cs typeface="Calibri" pitchFamily="34" charset="-120"/>
-              </a:rPr>
-              <a:t>Held items are tracked from the arm's own joint angles, like a real robot.</a:t>
-            </a:r>
-            <a:endParaRPr lang="en-US" sz="1600" dirty="0"/>
+              <a:t>Runs on an ordinary Intel laptop with OpenVINO. Skills teach themselves from auto-recorded demos — no hand-collected data.</a:t>
+            </a:r>
+            <a:endParaRPr lang="en-US" sz="1300" dirty="0"/>
           </a:p>
         </p:txBody>
       </p:sp>
@@ -3645,15 +3625,725 @@
                 <a:ea typeface="Arial" pitchFamily="34" charset="-122"/>
                 <a:cs typeface="Arial" pitchFamily="34" charset="-120"/>
               </a:rPr>
-              <a:t>Teamwork, and it fixes its own mistakes</a:t>
+              <a:t>Observe, understand, plan, act, look again</a:t>
             </a:r>
             <a:endParaRPr lang="en-US" sz="3000" dirty="0"/>
+          </a:p>
+        </p:txBody>
+      </p:sp>
+      <p:sp>
+        <p:nvSpPr>
+          <p:cNvPr id="3" name="Shape 1"/>
+          <p:cNvSpPr/>
+          <p:nvPr/>
+        </p:nvSpPr>
+        <p:spPr>
+          <a:xfrm>
+            <a:off x="457200" y="1143000"/>
+            <a:ext cx="384048" cy="384048"/>
+          </a:xfrm>
+          <a:prstGeom prst="ellipse">
+            <a:avLst/>
+          </a:prstGeom>
+          <a:solidFill>
+            <a:srgbClr val="E8B923"/>
+          </a:solidFill>
+          <a:ln w="12700">
+            <a:solidFill>
+              <a:srgbClr val="E8B923"/>
+            </a:solidFill>
+            <a:prstDash val="solid"/>
+          </a:ln>
+        </p:spPr>
+      </p:sp>
+      <p:sp>
+        <p:nvSpPr>
+          <p:cNvPr id="4" name="Text 2"/>
+          <p:cNvSpPr txBox="1"/>
+          <p:nvPr/>
+        </p:nvSpPr>
+        <p:spPr>
+          <a:xfrm>
+            <a:off x="457200" y="1143000"/>
+            <a:ext cx="384048" cy="384048"/>
+          </a:xfrm>
+          <a:prstGeom prst="rect">
+            <a:avLst/>
+          </a:prstGeom>
+          <a:noFill/>
+          <a:ln/>
+        </p:spPr>
+        <p:txBody>
+          <a:bodyPr wrap="square" lIns="0" tIns="0" rIns="0" bIns="0" rtlCol="0" anchor="ctr"/>
+          <a:lstStyle/>
+          <a:p>
+            <a:pPr algn="ctr" indent="0" marL="0">
+              <a:buNone/>
+            </a:pPr>
+            <a:r>
+              <a:rPr lang="en-US" sz="1400" b="1" dirty="0">
+                <a:solidFill>
+                  <a:srgbClr val="161B22"/>
+                </a:solidFill>
+                <a:latin typeface="Arial" pitchFamily="34" charset="0"/>
+                <a:ea typeface="Arial" pitchFamily="34" charset="-122"/>
+                <a:cs typeface="Arial" pitchFamily="34" charset="-120"/>
+              </a:rPr>
+              <a:t>1</a:t>
+            </a:r>
+            <a:endParaRPr lang="en-US" sz="1400" dirty="0"/>
+          </a:p>
+        </p:txBody>
+      </p:sp>
+      <p:sp>
+        <p:nvSpPr>
+          <p:cNvPr id="5" name="Text 3"/>
+          <p:cNvSpPr txBox="1"/>
+          <p:nvPr/>
+        </p:nvSpPr>
+        <p:spPr>
+          <a:xfrm>
+            <a:off x="457200" y="1627632"/>
+            <a:ext cx="1554480" cy="320040"/>
+          </a:xfrm>
+          <a:prstGeom prst="rect">
+            <a:avLst/>
+          </a:prstGeom>
+          <a:noFill/>
+          <a:ln/>
+        </p:spPr>
+        <p:txBody>
+          <a:bodyPr wrap="square" lIns="0" tIns="0" rIns="0" bIns="0" rtlCol="0" anchor="ctr"/>
+          <a:lstStyle/>
+          <a:p>
+            <a:pPr indent="0" marL="0">
+              <a:buNone/>
+            </a:pPr>
+            <a:r>
+              <a:rPr lang="en-US" sz="1500" b="1" dirty="0">
+                <a:solidFill>
+                  <a:srgbClr val="FFFFFF"/>
+                </a:solidFill>
+                <a:latin typeface="Arial" pitchFamily="34" charset="0"/>
+                <a:ea typeface="Arial" pitchFamily="34" charset="-122"/>
+                <a:cs typeface="Arial" pitchFamily="34" charset="-120"/>
+              </a:rPr>
+              <a:t>Observe</a:t>
+            </a:r>
+            <a:endParaRPr lang="en-US" sz="1500" dirty="0"/>
+          </a:p>
+        </p:txBody>
+      </p:sp>
+      <p:sp>
+        <p:nvSpPr>
+          <p:cNvPr id="6" name="Text 4"/>
+          <p:cNvSpPr txBox="1"/>
+          <p:nvPr/>
+        </p:nvSpPr>
+        <p:spPr>
+          <a:xfrm>
+            <a:off x="457200" y="1938528"/>
+            <a:ext cx="1508760" cy="822960"/>
+          </a:xfrm>
+          <a:prstGeom prst="rect">
+            <a:avLst/>
+          </a:prstGeom>
+          <a:noFill/>
+          <a:ln/>
+        </p:spPr>
+        <p:txBody>
+          <a:bodyPr wrap="square" lIns="0" tIns="0" rIns="0" bIns="0" rtlCol="0" anchor="t"/>
+          <a:lstStyle/>
+          <a:p>
+            <a:pPr indent="0" marL="0">
+              <a:buNone/>
+            </a:pPr>
+            <a:r>
+              <a:rPr lang="en-US" sz="1200" dirty="0">
+                <a:solidFill>
+                  <a:srgbClr val="9AA7B5"/>
+                </a:solidFill>
+                <a:latin typeface="Calibri" pitchFamily="34" charset="0"/>
+                <a:ea typeface="Calibri" pitchFamily="34" charset="-122"/>
+                <a:cs typeface="Calibri" pitchFamily="34" charset="-120"/>
+              </a:rPr>
+              <a:t>overhead colour + depth camera finds every object</a:t>
+            </a:r>
+            <a:endParaRPr lang="en-US" sz="1200" dirty="0"/>
+          </a:p>
+        </p:txBody>
+      </p:sp>
+      <p:sp>
+        <p:nvSpPr>
+          <p:cNvPr id="7" name="Shape 5"/>
+          <p:cNvSpPr/>
+          <p:nvPr/>
+        </p:nvSpPr>
+        <p:spPr>
+          <a:xfrm>
+            <a:off x="2121408" y="1143000"/>
+            <a:ext cx="384048" cy="384048"/>
+          </a:xfrm>
+          <a:prstGeom prst="ellipse">
+            <a:avLst/>
+          </a:prstGeom>
+          <a:solidFill>
+            <a:srgbClr val="E8B923"/>
+          </a:solidFill>
+          <a:ln w="12700">
+            <a:solidFill>
+              <a:srgbClr val="E8B923"/>
+            </a:solidFill>
+            <a:prstDash val="solid"/>
+          </a:ln>
+        </p:spPr>
+      </p:sp>
+      <p:sp>
+        <p:nvSpPr>
+          <p:cNvPr id="8" name="Text 6"/>
+          <p:cNvSpPr txBox="1"/>
+          <p:nvPr/>
+        </p:nvSpPr>
+        <p:spPr>
+          <a:xfrm>
+            <a:off x="2121408" y="1143000"/>
+            <a:ext cx="384048" cy="384048"/>
+          </a:xfrm>
+          <a:prstGeom prst="rect">
+            <a:avLst/>
+          </a:prstGeom>
+          <a:noFill/>
+          <a:ln/>
+        </p:spPr>
+        <p:txBody>
+          <a:bodyPr wrap="square" lIns="0" tIns="0" rIns="0" bIns="0" rtlCol="0" anchor="ctr"/>
+          <a:lstStyle/>
+          <a:p>
+            <a:pPr algn="ctr" indent="0" marL="0">
+              <a:buNone/>
+            </a:pPr>
+            <a:r>
+              <a:rPr lang="en-US" sz="1400" b="1" dirty="0">
+                <a:solidFill>
+                  <a:srgbClr val="161B22"/>
+                </a:solidFill>
+                <a:latin typeface="Arial" pitchFamily="34" charset="0"/>
+                <a:ea typeface="Arial" pitchFamily="34" charset="-122"/>
+                <a:cs typeface="Arial" pitchFamily="34" charset="-120"/>
+              </a:rPr>
+              <a:t>2</a:t>
+            </a:r>
+            <a:endParaRPr lang="en-US" sz="1400" dirty="0"/>
+          </a:p>
+        </p:txBody>
+      </p:sp>
+      <p:sp>
+        <p:nvSpPr>
+          <p:cNvPr id="9" name="Text 7"/>
+          <p:cNvSpPr txBox="1"/>
+          <p:nvPr/>
+        </p:nvSpPr>
+        <p:spPr>
+          <a:xfrm>
+            <a:off x="2121408" y="1627632"/>
+            <a:ext cx="1554480" cy="320040"/>
+          </a:xfrm>
+          <a:prstGeom prst="rect">
+            <a:avLst/>
+          </a:prstGeom>
+          <a:noFill/>
+          <a:ln/>
+        </p:spPr>
+        <p:txBody>
+          <a:bodyPr wrap="square" lIns="0" tIns="0" rIns="0" bIns="0" rtlCol="0" anchor="ctr"/>
+          <a:lstStyle/>
+          <a:p>
+            <a:pPr indent="0" marL="0">
+              <a:buNone/>
+            </a:pPr>
+            <a:r>
+              <a:rPr lang="en-US" sz="1500" b="1" dirty="0">
+                <a:solidFill>
+                  <a:srgbClr val="FFFFFF"/>
+                </a:solidFill>
+                <a:latin typeface="Arial" pitchFamily="34" charset="0"/>
+                <a:ea typeface="Arial" pitchFamily="34" charset="-122"/>
+                <a:cs typeface="Arial" pitchFamily="34" charset="-120"/>
+              </a:rPr>
+              <a:t>Understand</a:t>
+            </a:r>
+            <a:endParaRPr lang="en-US" sz="1500" dirty="0"/>
+          </a:p>
+        </p:txBody>
+      </p:sp>
+      <p:sp>
+        <p:nvSpPr>
+          <p:cNvPr id="10" name="Text 8"/>
+          <p:cNvSpPr txBox="1"/>
+          <p:nvPr/>
+        </p:nvSpPr>
+        <p:spPr>
+          <a:xfrm>
+            <a:off x="2121408" y="1938528"/>
+            <a:ext cx="1508760" cy="822960"/>
+          </a:xfrm>
+          <a:prstGeom prst="rect">
+            <a:avLst/>
+          </a:prstGeom>
+          <a:noFill/>
+          <a:ln/>
+        </p:spPr>
+        <p:txBody>
+          <a:bodyPr wrap="square" lIns="0" tIns="0" rIns="0" bIns="0" rtlCol="0" anchor="t"/>
+          <a:lstStyle/>
+          <a:p>
+            <a:pPr indent="0" marL="0">
+              <a:buNone/>
+            </a:pPr>
+            <a:r>
+              <a:rPr lang="en-US" sz="1200" dirty="0">
+                <a:solidFill>
+                  <a:srgbClr val="9AA7B5"/>
+                </a:solidFill>
+                <a:latin typeface="Calibri" pitchFamily="34" charset="0"/>
+                <a:ea typeface="Calibri" pitchFamily="34" charset="-122"/>
+                <a:cs typeface="Calibri" pitchFamily="34" charset="-120"/>
+              </a:rPr>
+              <a:t>Qwen3-VL-4B on OpenVINO reads the command and the picture</a:t>
+            </a:r>
+            <a:endParaRPr lang="en-US" sz="1200" dirty="0"/>
+          </a:p>
+        </p:txBody>
+      </p:sp>
+      <p:sp>
+        <p:nvSpPr>
+          <p:cNvPr id="11" name="Shape 9"/>
+          <p:cNvSpPr/>
+          <p:nvPr/>
+        </p:nvSpPr>
+        <p:spPr>
+          <a:xfrm>
+            <a:off x="3785616" y="1143000"/>
+            <a:ext cx="384048" cy="384048"/>
+          </a:xfrm>
+          <a:prstGeom prst="ellipse">
+            <a:avLst/>
+          </a:prstGeom>
+          <a:solidFill>
+            <a:srgbClr val="E8B923"/>
+          </a:solidFill>
+          <a:ln w="12700">
+            <a:solidFill>
+              <a:srgbClr val="E8B923"/>
+            </a:solidFill>
+            <a:prstDash val="solid"/>
+          </a:ln>
+        </p:spPr>
+      </p:sp>
+      <p:sp>
+        <p:nvSpPr>
+          <p:cNvPr id="12" name="Text 10"/>
+          <p:cNvSpPr txBox="1"/>
+          <p:nvPr/>
+        </p:nvSpPr>
+        <p:spPr>
+          <a:xfrm>
+            <a:off x="3785616" y="1143000"/>
+            <a:ext cx="384048" cy="384048"/>
+          </a:xfrm>
+          <a:prstGeom prst="rect">
+            <a:avLst/>
+          </a:prstGeom>
+          <a:noFill/>
+          <a:ln/>
+        </p:spPr>
+        <p:txBody>
+          <a:bodyPr wrap="square" lIns="0" tIns="0" rIns="0" bIns="0" rtlCol="0" anchor="ctr"/>
+          <a:lstStyle/>
+          <a:p>
+            <a:pPr algn="ctr" indent="0" marL="0">
+              <a:buNone/>
+            </a:pPr>
+            <a:r>
+              <a:rPr lang="en-US" sz="1400" b="1" dirty="0">
+                <a:solidFill>
+                  <a:srgbClr val="161B22"/>
+                </a:solidFill>
+                <a:latin typeface="Arial" pitchFamily="34" charset="0"/>
+                <a:ea typeface="Arial" pitchFamily="34" charset="-122"/>
+                <a:cs typeface="Arial" pitchFamily="34" charset="-120"/>
+              </a:rPr>
+              <a:t>3</a:t>
+            </a:r>
+            <a:endParaRPr lang="en-US" sz="1400" dirty="0"/>
+          </a:p>
+        </p:txBody>
+      </p:sp>
+      <p:sp>
+        <p:nvSpPr>
+          <p:cNvPr id="13" name="Text 11"/>
+          <p:cNvSpPr txBox="1"/>
+          <p:nvPr/>
+        </p:nvSpPr>
+        <p:spPr>
+          <a:xfrm>
+            <a:off x="3785616" y="1627632"/>
+            <a:ext cx="1554480" cy="320040"/>
+          </a:xfrm>
+          <a:prstGeom prst="rect">
+            <a:avLst/>
+          </a:prstGeom>
+          <a:noFill/>
+          <a:ln/>
+        </p:spPr>
+        <p:txBody>
+          <a:bodyPr wrap="square" lIns="0" tIns="0" rIns="0" bIns="0" rtlCol="0" anchor="ctr"/>
+          <a:lstStyle/>
+          <a:p>
+            <a:pPr indent="0" marL="0">
+              <a:buNone/>
+            </a:pPr>
+            <a:r>
+              <a:rPr lang="en-US" sz="1500" b="1" dirty="0">
+                <a:solidFill>
+                  <a:srgbClr val="FFFFFF"/>
+                </a:solidFill>
+                <a:latin typeface="Arial" pitchFamily="34" charset="0"/>
+                <a:ea typeface="Arial" pitchFamily="34" charset="-122"/>
+                <a:cs typeface="Arial" pitchFamily="34" charset="-120"/>
+              </a:rPr>
+              <a:t>Plan</a:t>
+            </a:r>
+            <a:endParaRPr lang="en-US" sz="1500" dirty="0"/>
+          </a:p>
+        </p:txBody>
+      </p:sp>
+      <p:sp>
+        <p:nvSpPr>
+          <p:cNvPr id="14" name="Text 12"/>
+          <p:cNvSpPr txBox="1"/>
+          <p:nvPr/>
+        </p:nvSpPr>
+        <p:spPr>
+          <a:xfrm>
+            <a:off x="3785616" y="1938528"/>
+            <a:ext cx="1508760" cy="822960"/>
+          </a:xfrm>
+          <a:prstGeom prst="rect">
+            <a:avLst/>
+          </a:prstGeom>
+          <a:noFill/>
+          <a:ln/>
+        </p:spPr>
+        <p:txBody>
+          <a:bodyPr wrap="square" lIns="0" tIns="0" rIns="0" bIns="0" rtlCol="0" anchor="t"/>
+          <a:lstStyle/>
+          <a:p>
+            <a:pPr indent="0" marL="0">
+              <a:buNone/>
+            </a:pPr>
+            <a:r>
+              <a:rPr lang="en-US" sz="1200" dirty="0">
+                <a:solidFill>
+                  <a:srgbClr val="9AA7B5"/>
+                </a:solidFill>
+                <a:latin typeface="Calibri" pitchFamily="34" charset="0"/>
+                <a:ea typeface="Calibri" pitchFamily="34" charset="-122"/>
+                <a:cs typeface="Calibri" pitchFamily="34" charset="-120"/>
+              </a:rPr>
+              <a:t>which arm, hand-off or set-down swap, what first</a:t>
+            </a:r>
+            <a:endParaRPr lang="en-US" sz="1200" dirty="0"/>
+          </a:p>
+        </p:txBody>
+      </p:sp>
+      <p:sp>
+        <p:nvSpPr>
+          <p:cNvPr id="15" name="Shape 13"/>
+          <p:cNvSpPr/>
+          <p:nvPr/>
+        </p:nvSpPr>
+        <p:spPr>
+          <a:xfrm>
+            <a:off x="5449824" y="1143000"/>
+            <a:ext cx="384048" cy="384048"/>
+          </a:xfrm>
+          <a:prstGeom prst="ellipse">
+            <a:avLst/>
+          </a:prstGeom>
+          <a:solidFill>
+            <a:srgbClr val="E8B923"/>
+          </a:solidFill>
+          <a:ln w="12700">
+            <a:solidFill>
+              <a:srgbClr val="E8B923"/>
+            </a:solidFill>
+            <a:prstDash val="solid"/>
+          </a:ln>
+        </p:spPr>
+      </p:sp>
+      <p:sp>
+        <p:nvSpPr>
+          <p:cNvPr id="16" name="Text 14"/>
+          <p:cNvSpPr txBox="1"/>
+          <p:nvPr/>
+        </p:nvSpPr>
+        <p:spPr>
+          <a:xfrm>
+            <a:off x="5449824" y="1143000"/>
+            <a:ext cx="384048" cy="384048"/>
+          </a:xfrm>
+          <a:prstGeom prst="rect">
+            <a:avLst/>
+          </a:prstGeom>
+          <a:noFill/>
+          <a:ln/>
+        </p:spPr>
+        <p:txBody>
+          <a:bodyPr wrap="square" lIns="0" tIns="0" rIns="0" bIns="0" rtlCol="0" anchor="ctr"/>
+          <a:lstStyle/>
+          <a:p>
+            <a:pPr algn="ctr" indent="0" marL="0">
+              <a:buNone/>
+            </a:pPr>
+            <a:r>
+              <a:rPr lang="en-US" sz="1400" b="1" dirty="0">
+                <a:solidFill>
+                  <a:srgbClr val="161B22"/>
+                </a:solidFill>
+                <a:latin typeface="Arial" pitchFamily="34" charset="0"/>
+                <a:ea typeface="Arial" pitchFamily="34" charset="-122"/>
+                <a:cs typeface="Arial" pitchFamily="34" charset="-120"/>
+              </a:rPr>
+              <a:t>4</a:t>
+            </a:r>
+            <a:endParaRPr lang="en-US" sz="1400" dirty="0"/>
+          </a:p>
+        </p:txBody>
+      </p:sp>
+      <p:sp>
+        <p:nvSpPr>
+          <p:cNvPr id="17" name="Text 15"/>
+          <p:cNvSpPr txBox="1"/>
+          <p:nvPr/>
+        </p:nvSpPr>
+        <p:spPr>
+          <a:xfrm>
+            <a:off x="5449824" y="1627632"/>
+            <a:ext cx="1554480" cy="320040"/>
+          </a:xfrm>
+          <a:prstGeom prst="rect">
+            <a:avLst/>
+          </a:prstGeom>
+          <a:noFill/>
+          <a:ln/>
+        </p:spPr>
+        <p:txBody>
+          <a:bodyPr wrap="square" lIns="0" tIns="0" rIns="0" bIns="0" rtlCol="0" anchor="ctr"/>
+          <a:lstStyle/>
+          <a:p>
+            <a:pPr indent="0" marL="0">
+              <a:buNone/>
+            </a:pPr>
+            <a:r>
+              <a:rPr lang="en-US" sz="1500" b="1" dirty="0">
+                <a:solidFill>
+                  <a:srgbClr val="FFFFFF"/>
+                </a:solidFill>
+                <a:latin typeface="Arial" pitchFamily="34" charset="0"/>
+                <a:ea typeface="Arial" pitchFamily="34" charset="-122"/>
+                <a:cs typeface="Arial" pitchFamily="34" charset="-120"/>
+              </a:rPr>
+              <a:t>Act</a:t>
+            </a:r>
+            <a:endParaRPr lang="en-US" sz="1500" dirty="0"/>
+          </a:p>
+        </p:txBody>
+      </p:sp>
+      <p:sp>
+        <p:nvSpPr>
+          <p:cNvPr id="18" name="Text 16"/>
+          <p:cNvSpPr txBox="1"/>
+          <p:nvPr/>
+        </p:nvSpPr>
+        <p:spPr>
+          <a:xfrm>
+            <a:off x="5449824" y="1938528"/>
+            <a:ext cx="1508760" cy="822960"/>
+          </a:xfrm>
+          <a:prstGeom prst="rect">
+            <a:avLst/>
+          </a:prstGeom>
+          <a:noFill/>
+          <a:ln/>
+        </p:spPr>
+        <p:txBody>
+          <a:bodyPr wrap="square" lIns="0" tIns="0" rIns="0" bIns="0" rtlCol="0" anchor="t"/>
+          <a:lstStyle/>
+          <a:p>
+            <a:pPr indent="0" marL="0">
+              <a:buNone/>
+            </a:pPr>
+            <a:r>
+              <a:rPr lang="en-US" sz="1200" dirty="0">
+                <a:solidFill>
+                  <a:srgbClr val="9AA7B5"/>
+                </a:solidFill>
+                <a:latin typeface="Calibri" pitchFamily="34" charset="0"/>
+                <a:ea typeface="Calibri" pitchFamily="34" charset="-122"/>
+                <a:cs typeface="Calibri" pitchFamily="34" charset="-120"/>
+              </a:rPr>
+              <a:t>two SO-101 arms; a trained ACT policy for the mug</a:t>
+            </a:r>
+            <a:endParaRPr lang="en-US" sz="1200" dirty="0"/>
+          </a:p>
+        </p:txBody>
+      </p:sp>
+      <p:sp>
+        <p:nvSpPr>
+          <p:cNvPr id="19" name="Shape 17"/>
+          <p:cNvSpPr/>
+          <p:nvPr/>
+        </p:nvSpPr>
+        <p:spPr>
+          <a:xfrm>
+            <a:off x="7114032" y="1143000"/>
+            <a:ext cx="384048" cy="384048"/>
+          </a:xfrm>
+          <a:prstGeom prst="ellipse">
+            <a:avLst/>
+          </a:prstGeom>
+          <a:solidFill>
+            <a:srgbClr val="E8B923"/>
+          </a:solidFill>
+          <a:ln w="12700">
+            <a:solidFill>
+              <a:srgbClr val="E8B923"/>
+            </a:solidFill>
+            <a:prstDash val="solid"/>
+          </a:ln>
+        </p:spPr>
+      </p:sp>
+      <p:sp>
+        <p:nvSpPr>
+          <p:cNvPr id="20" name="Text 18"/>
+          <p:cNvSpPr txBox="1"/>
+          <p:nvPr/>
+        </p:nvSpPr>
+        <p:spPr>
+          <a:xfrm>
+            <a:off x="7114032" y="1143000"/>
+            <a:ext cx="384048" cy="384048"/>
+          </a:xfrm>
+          <a:prstGeom prst="rect">
+            <a:avLst/>
+          </a:prstGeom>
+          <a:noFill/>
+          <a:ln/>
+        </p:spPr>
+        <p:txBody>
+          <a:bodyPr wrap="square" lIns="0" tIns="0" rIns="0" bIns="0" rtlCol="0" anchor="ctr"/>
+          <a:lstStyle/>
+          <a:p>
+            <a:pPr algn="ctr" indent="0" marL="0">
+              <a:buNone/>
+            </a:pPr>
+            <a:r>
+              <a:rPr lang="en-US" sz="1400" b="1" dirty="0">
+                <a:solidFill>
+                  <a:srgbClr val="161B22"/>
+                </a:solidFill>
+                <a:latin typeface="Arial" pitchFamily="34" charset="0"/>
+                <a:ea typeface="Arial" pitchFamily="34" charset="-122"/>
+                <a:cs typeface="Arial" pitchFamily="34" charset="-120"/>
+              </a:rPr>
+              <a:t>5</a:t>
+            </a:r>
+            <a:endParaRPr lang="en-US" sz="1400" dirty="0"/>
+          </a:p>
+        </p:txBody>
+      </p:sp>
+      <p:sp>
+        <p:nvSpPr>
+          <p:cNvPr id="21" name="Text 19"/>
+          <p:cNvSpPr txBox="1"/>
+          <p:nvPr/>
+        </p:nvSpPr>
+        <p:spPr>
+          <a:xfrm>
+            <a:off x="7114032" y="1627632"/>
+            <a:ext cx="1554480" cy="320040"/>
+          </a:xfrm>
+          <a:prstGeom prst="rect">
+            <a:avLst/>
+          </a:prstGeom>
+          <a:noFill/>
+          <a:ln/>
+        </p:spPr>
+        <p:txBody>
+          <a:bodyPr wrap="square" lIns="0" tIns="0" rIns="0" bIns="0" rtlCol="0" anchor="ctr"/>
+          <a:lstStyle/>
+          <a:p>
+            <a:pPr indent="0" marL="0">
+              <a:buNone/>
+            </a:pPr>
+            <a:r>
+              <a:rPr lang="en-US" sz="1500" b="1" dirty="0">
+                <a:solidFill>
+                  <a:srgbClr val="FFFFFF"/>
+                </a:solidFill>
+                <a:latin typeface="Arial" pitchFamily="34" charset="0"/>
+                <a:ea typeface="Arial" pitchFamily="34" charset="-122"/>
+                <a:cs typeface="Arial" pitchFamily="34" charset="-120"/>
+              </a:rPr>
+              <a:t>Look again</a:t>
+            </a:r>
+            <a:endParaRPr lang="en-US" sz="1500" dirty="0"/>
+          </a:p>
+        </p:txBody>
+      </p:sp>
+      <p:sp>
+        <p:nvSpPr>
+          <p:cNvPr id="22" name="Text 20"/>
+          <p:cNvSpPr txBox="1"/>
+          <p:nvPr/>
+        </p:nvSpPr>
+        <p:spPr>
+          <a:xfrm>
+            <a:off x="7114032" y="1938528"/>
+            <a:ext cx="1508760" cy="822960"/>
+          </a:xfrm>
+          <a:prstGeom prst="rect">
+            <a:avLst/>
+          </a:prstGeom>
+          <a:noFill/>
+          <a:ln/>
+        </p:spPr>
+        <p:txBody>
+          <a:bodyPr wrap="square" lIns="0" tIns="0" rIns="0" bIns="0" rtlCol="0" anchor="t"/>
+          <a:lstStyle/>
+          <a:p>
+            <a:pPr indent="0" marL="0">
+              <a:buNone/>
+            </a:pPr>
+            <a:r>
+              <a:rPr lang="en-US" sz="1200" dirty="0">
+                <a:solidFill>
+                  <a:srgbClr val="9AA7B5"/>
+                </a:solidFill>
+                <a:latin typeface="Calibri" pitchFamily="34" charset="0"/>
+                <a:ea typeface="Calibri" pitchFamily="34" charset="-122"/>
+                <a:cs typeface="Calibri" pitchFamily="34" charset="-120"/>
+              </a:rPr>
+              <a:t>anything knocked out of place is fixed first</a:t>
+            </a:r>
+            <a:endParaRPr lang="en-US" sz="1200" dirty="0"/>
           </a:p>
         </p:txBody>
       </p:sp>
       <p:pic>
         <p:nvPicPr>
-          <p:cNvPr id="3" name="Image 0" descr="C:\DriveSync\Creative\hackathons\ai-infra-summit-2026\submission\img\handoff_crop.png">    </p:cNvPr>
+          <p:cNvPr id="23" name="Image 0" descr="C:\DriveSync\Creative\hackathons\ai-infra-summit-2026\submission\img\eyes.png">    </p:cNvPr>
           <p:cNvPicPr>
             <a:picLocks noChangeAspect="1"/>
           </p:cNvPicPr>
@@ -3667,8 +4357,8 @@
         </p:blipFill>
         <p:spPr>
           <a:xfrm>
-            <a:off x="457200" y="1188720"/>
-            <a:ext cx="4023360" cy="2523744"/>
+            <a:off x="457200" y="2926080"/>
+            <a:ext cx="2560320" cy="1920240"/>
           </a:xfrm>
           <a:prstGeom prst="rect">
             <a:avLst/>
@@ -3677,14 +4367,14 @@
       </p:pic>
       <p:sp>
         <p:nvSpPr>
-          <p:cNvPr id="4" name="Text 1"/>
-          <p:cNvSpPr txBox="1"/>
-          <p:nvPr/>
-        </p:nvSpPr>
-        <p:spPr>
-          <a:xfrm>
-            <a:off x="457200" y="3794760"/>
-            <a:ext cx="4023360" cy="1188720"/>
+          <p:cNvPr id="24" name="Text 21"/>
+          <p:cNvSpPr txBox="1"/>
+          <p:nvPr/>
+        </p:nvSpPr>
+        <p:spPr>
+          <a:xfrm>
+            <a:off x="3291840" y="2971800"/>
+            <a:ext cx="5394960" cy="1828800"/>
           </a:xfrm>
           <a:prstGeom prst="rect">
             <a:avLst/>
@@ -3708,7 +4398,7 @@
                 <a:ea typeface="Calibri" pitchFamily="34" charset="-122"/>
                 <a:cs typeface="Calibri" pitchFamily="34" charset="-120"/>
               </a:rPr>
-              <a:t>Hand-off</a:t>
+              <a:t>What the robot sees</a:t>
             </a:r>
             <a:endParaRPr lang="en-US" sz="1600" dirty="0"/>
           </a:p>
@@ -3725,189 +4415,41 @@
                 <a:ea typeface="Calibri" pitchFamily="34" charset="-122"/>
                 <a:cs typeface="Calibri" pitchFamily="34" charset="-120"/>
               </a:rPr>
-              <a:t>The fork starts on arm B's side but belongs on arm A's. B carries it in, A moves up at the same time, lines up 1.5 mm away, grips, then B lets go.</a:t>
+              <a:t>Objects are found from the height map and their shape, never from the simulator. On 20 random tables every object was found, 0.5 mm average error.</a:t>
             </a:r>
             <a:endParaRPr lang="en-US" sz="1600" dirty="0"/>
           </a:p>
-        </p:txBody>
-      </p:sp>
-      <p:pic>
-        <p:nvPicPr>
-          <p:cNvPr id="5" name="Image 1" descr="C:\DriveSync\Creative\hackathons\ai-infra-summit-2026\submission\img\recovery_bumped.png">    </p:cNvPr>
-          <p:cNvPicPr>
-            <a:picLocks noChangeAspect="1"/>
-          </p:cNvPicPr>
-          <p:nvPr/>
-        </p:nvPicPr>
-        <p:blipFill>
-          <a:blip r:embed="rId2"/>
-          <a:stretch>
-            <a:fillRect/>
-          </a:stretch>
-        </p:blipFill>
-        <p:spPr>
-          <a:xfrm>
-            <a:off x="4754880" y="1188720"/>
-            <a:ext cx="1920240" cy="1444752"/>
-          </a:xfrm>
-          <a:prstGeom prst="rect">
-            <a:avLst/>
-          </a:prstGeom>
-        </p:spPr>
-      </p:pic>
-      <p:pic>
-        <p:nvPicPr>
-          <p:cNvPr id="6" name="Image 2" descr="C:\DriveSync\Creative\hackathons\ai-infra-summit-2026\submission\img\recovery_fixed.png">    </p:cNvPr>
-          <p:cNvPicPr>
-            <a:picLocks noChangeAspect="1"/>
-          </p:cNvPicPr>
-          <p:nvPr/>
-        </p:nvPicPr>
-        <p:blipFill>
-          <a:blip r:embed="rId3"/>
-          <a:stretch>
-            <a:fillRect/>
-          </a:stretch>
-        </p:blipFill>
-        <p:spPr>
-          <a:xfrm>
-            <a:off x="6766560" y="1188720"/>
-            <a:ext cx="1920240" cy="1444752"/>
-          </a:xfrm>
-          <a:prstGeom prst="rect">
-            <a:avLst/>
-          </a:prstGeom>
-        </p:spPr>
-      </p:pic>
-      <p:sp>
-        <p:nvSpPr>
-          <p:cNvPr id="7" name="Text 2"/>
-          <p:cNvSpPr txBox="1"/>
-          <p:nvPr/>
-        </p:nvSpPr>
-        <p:spPr>
-          <a:xfrm>
-            <a:off x="4754880" y="2670048"/>
-            <a:ext cx="1920240" cy="274320"/>
-          </a:xfrm>
-          <a:prstGeom prst="rect">
-            <a:avLst/>
-          </a:prstGeom>
-          <a:noFill/>
-          <a:ln/>
-        </p:spPr>
-        <p:txBody>
-          <a:bodyPr wrap="square" lIns="0" tIns="0" rIns="0" bIns="0" rtlCol="0" anchor="ctr"/>
-          <a:lstStyle/>
-          <a:p>
-            <a:pPr algn="ctr" indent="0" marL="0">
-              <a:buNone/>
-            </a:pPr>
-            <a:r>
-              <a:rPr lang="en-US" sz="1200" dirty="0">
-                <a:solidFill>
-                  <a:srgbClr val="F87171"/>
+          <a:p>
+            <a:pPr indent="0" marL="0">
+              <a:buNone/>
+            </a:pPr>
+            <a:r>
+              <a:rPr lang="en-US" sz="800" dirty="0">
+                <a:solidFill>
+                  <a:srgbClr val="000000"/>
                 </a:solidFill>
                 <a:latin typeface="Calibri" pitchFamily="34" charset="0"/>
                 <a:ea typeface="Calibri" pitchFamily="34" charset="-122"/>
                 <a:cs typeface="Calibri" pitchFamily="34" charset="-120"/>
               </a:rPr>
-              <a:t>knocked</a:t>
-            </a:r>
-            <a:endParaRPr lang="en-US" sz="1200" dirty="0"/>
-          </a:p>
-        </p:txBody>
-      </p:sp>
-      <p:sp>
-        <p:nvSpPr>
-          <p:cNvPr id="8" name="Text 3"/>
-          <p:cNvSpPr txBox="1"/>
-          <p:nvPr/>
-        </p:nvSpPr>
-        <p:spPr>
-          <a:xfrm>
-            <a:off x="6766560" y="2670048"/>
-            <a:ext cx="1920240" cy="274320"/>
-          </a:xfrm>
-          <a:prstGeom prst="rect">
-            <a:avLst/>
-          </a:prstGeom>
-          <a:noFill/>
-          <a:ln/>
-        </p:spPr>
-        <p:txBody>
-          <a:bodyPr wrap="square" lIns="0" tIns="0" rIns="0" bIns="0" rtlCol="0" anchor="ctr"/>
-          <a:lstStyle/>
-          <a:p>
-            <a:pPr algn="ctr" indent="0" marL="0">
-              <a:buNone/>
-            </a:pPr>
-            <a:r>
-              <a:rPr lang="en-US" sz="1200" dirty="0">
-                <a:solidFill>
-                  <a:srgbClr val="4ADE80"/>
+              <a:t> </a:t>
+            </a:r>
+            <a:endParaRPr lang="en-US" sz="1600" dirty="0"/>
+          </a:p>
+          <a:p>
+            <a:pPr indent="0" marL="0">
+              <a:buNone/>
+            </a:pPr>
+            <a:r>
+              <a:rPr lang="en-US" sz="1300" dirty="0">
+                <a:solidFill>
+                  <a:srgbClr val="9AA7B5"/>
                 </a:solidFill>
                 <a:latin typeface="Calibri" pitchFamily="34" charset="0"/>
                 <a:ea typeface="Calibri" pitchFamily="34" charset="-122"/>
                 <a:cs typeface="Calibri" pitchFamily="34" charset="-120"/>
               </a:rPr>
-              <a:t>seen and fixed</a:t>
-            </a:r>
-            <a:endParaRPr lang="en-US" sz="1200" dirty="0"/>
-          </a:p>
-        </p:txBody>
-      </p:sp>
-      <p:sp>
-        <p:nvSpPr>
-          <p:cNvPr id="9" name="Text 4"/>
-          <p:cNvSpPr txBox="1"/>
-          <p:nvPr/>
-        </p:nvSpPr>
-        <p:spPr>
-          <a:xfrm>
-            <a:off x="4754880" y="3063240"/>
-            <a:ext cx="3931920" cy="1463040"/>
-          </a:xfrm>
-          <a:prstGeom prst="rect">
-            <a:avLst/>
-          </a:prstGeom>
-          <a:noFill/>
-          <a:ln/>
-        </p:spPr>
-        <p:txBody>
-          <a:bodyPr wrap="square" lIns="0" tIns="0" rIns="0" bIns="0" rtlCol="0" anchor="t"/>
-          <a:lstStyle/>
-          <a:p>
-            <a:pPr indent="0" marL="0">
-              <a:buNone/>
-            </a:pPr>
-            <a:r>
-              <a:rPr lang="en-US" sz="1600" b="1" dirty="0">
-                <a:solidFill>
-                  <a:srgbClr val="FFFFFF"/>
-                </a:solidFill>
-                <a:latin typeface="Calibri" pitchFamily="34" charset="0"/>
-                <a:ea typeface="Calibri" pitchFamily="34" charset="-122"/>
-                <a:cs typeface="Calibri" pitchFamily="34" charset="-120"/>
-              </a:rPr>
-              <a:t>Recovery</a:t>
-            </a:r>
-            <a:endParaRPr lang="en-US" sz="1600" dirty="0"/>
-          </a:p>
-          <a:p>
-            <a:pPr indent="0" marL="0">
-              <a:buNone/>
-            </a:pPr>
-            <a:r>
-              <a:rPr lang="en-US" sz="1300" dirty="0">
-                <a:solidFill>
-                  <a:srgbClr val="9AA7B5"/>
-                </a:solidFill>
-                <a:latin typeface="Calibri" pitchFamily="34" charset="0"/>
-                <a:ea typeface="Calibri" pitchFamily="34" charset="-122"/>
-                <a:cs typeface="Calibri" pitchFamily="34" charset="-120"/>
-              </a:rPr>
-              <a:t>Mid-task, the plate is knocked 6 cm. After the next item the robot looks at everything it already placed, sees the plate has moved, and puts it back before carrying on.</a:t>
+              <a:t>Held items are tracked from the arm's own joint angles, like a real robot.</a:t>
             </a:r>
             <a:endParaRPr lang="en-US" sz="1600" dirty="0"/>
           </a:p>
@@ -3978,196 +4520,79 @@
                 <a:ea typeface="Arial" pitchFamily="34" charset="-122"/>
                 <a:cs typeface="Arial" pitchFamily="34" charset="-120"/>
               </a:rPr>
-              <a:t>Our own teacher trained the policy</a:t>
+              <a:t>Teamwork, and it fixes its own mistakes</a:t>
             </a:r>
             <a:endParaRPr lang="en-US" sz="3000" dirty="0"/>
           </a:p>
         </p:txBody>
       </p:sp>
-      <p:sp>
-        <p:nvSpPr>
-          <p:cNvPr id="3" name="Text 1"/>
-          <p:cNvSpPr txBox="1"/>
-          <p:nvPr/>
-        </p:nvSpPr>
-        <p:spPr>
-          <a:xfrm>
-            <a:off x="457200" y="804672"/>
-            <a:ext cx="8229600" cy="320040"/>
-          </a:xfrm>
-          <a:prstGeom prst="rect">
-            <a:avLst/>
-          </a:prstGeom>
-          <a:noFill/>
-          <a:ln/>
-        </p:spPr>
-        <p:txBody>
-          <a:bodyPr wrap="square" lIns="0" tIns="0" rIns="0" bIns="0" rtlCol="0" anchor="ctr"/>
+      <p:pic>
+        <p:nvPicPr>
+          <p:cNvPr id="3" name="Image 0" descr="C:\DriveSync\Creative\hackathons\ai-infra-summit-2026\submission\img\handoff_crop.png">    </p:cNvPr>
+          <p:cNvPicPr>
+            <a:picLocks noChangeAspect="1"/>
+          </p:cNvPicPr>
+          <p:nvPr/>
+        </p:nvPicPr>
+        <p:blipFill>
+          <a:blip r:embed="rId1"/>
+          <a:stretch>
+            <a:fillRect/>
+          </a:stretch>
+        </p:blipFill>
+        <p:spPr>
+          <a:xfrm>
+            <a:off x="457200" y="1188720"/>
+            <a:ext cx="4023360" cy="2523744"/>
+          </a:xfrm>
+          <a:prstGeom prst="rect">
+            <a:avLst/>
+          </a:prstGeom>
+        </p:spPr>
+      </p:pic>
+      <p:sp>
+        <p:nvSpPr>
+          <p:cNvPr id="4" name="Text 1"/>
+          <p:cNvSpPr txBox="1"/>
+          <p:nvPr/>
+        </p:nvSpPr>
+        <p:spPr>
+          <a:xfrm>
+            <a:off x="457200" y="3794760"/>
+            <a:ext cx="4023360" cy="1188720"/>
+          </a:xfrm>
+          <a:prstGeom prst="rect">
+            <a:avLst/>
+          </a:prstGeom>
+          <a:noFill/>
+          <a:ln/>
+        </p:spPr>
+        <p:txBody>
+          <a:bodyPr wrap="square" lIns="0" tIns="0" rIns="0" bIns="0" rtlCol="0" anchor="t"/>
           <a:lstStyle/>
           <a:p>
             <a:pPr indent="0" marL="0">
               <a:buNone/>
             </a:pPr>
             <a:r>
-              <a:rPr lang="en-US" sz="1400" dirty="0">
-                <a:solidFill>
-                  <a:srgbClr val="9AA7B5"/>
+              <a:rPr lang="en-US" sz="1600" b="1" dirty="0">
+                <a:solidFill>
+                  <a:srgbClr val="FFFFFF"/>
                 </a:solidFill>
                 <a:latin typeface="Calibri" pitchFamily="34" charset="0"/>
                 <a:ea typeface="Calibri" pitchFamily="34" charset="-122"/>
                 <a:cs typeface="Calibri" pitchFamily="34" charset="-120"/>
               </a:rPr>
-              <a:t>LeRobot ACT on a laptop CPU · 1,219 demonstrations recorded automatically · success on unseen tables</a:t>
-            </a:r>
-            <a:endParaRPr lang="en-US" sz="1400" dirty="0"/>
-          </a:p>
-        </p:txBody>
-      </p:sp>
-      <p:graphicFrame>
-        <p:nvGraphicFramePr>
-          <p:cNvPr id="4" name="Chart 0" descr=""/>
-          <p:cNvGraphicFramePr/>
-          <p:nvPr/>
-        </p:nvGraphicFramePr>
-        <p:xfrm>
-          <a:off x="365760" y="1234440"/>
-          <a:ext cx="4846320" cy="3566160"/>
-        </p:xfrm>
-        <a:graphic xmlns:a="http://schemas.openxmlformats.org/drawingml/2006/main">
-          <a:graphicData uri="http://schemas.openxmlformats.org/drawingml/2006/chart">
-            <c:chart xmlns:c="http://schemas.openxmlformats.org/drawingml/2006/chart" r:id="rId1"/>
-          </a:graphicData>
-        </a:graphic>
-      </p:graphicFrame>
-      <p:sp>
-        <p:nvSpPr>
-          <p:cNvPr id="5" name="Shape 2"/>
-          <p:cNvSpPr/>
-          <p:nvPr/>
-        </p:nvSpPr>
-        <p:spPr>
-          <a:xfrm>
-            <a:off x="5486400" y="1325880"/>
-            <a:ext cx="347472" cy="347472"/>
-          </a:xfrm>
-          <a:prstGeom prst="ellipse">
-            <a:avLst/>
-          </a:prstGeom>
-          <a:solidFill>
-            <a:srgbClr val="E8B923"/>
-          </a:solidFill>
-          <a:ln w="12700">
-            <a:solidFill>
-              <a:srgbClr val="E8B923"/>
-            </a:solidFill>
-            <a:prstDash val="solid"/>
-          </a:ln>
-        </p:spPr>
-      </p:sp>
-      <p:sp>
-        <p:nvSpPr>
-          <p:cNvPr id="6" name="Text 3"/>
-          <p:cNvSpPr txBox="1"/>
-          <p:nvPr/>
-        </p:nvSpPr>
-        <p:spPr>
-          <a:xfrm>
-            <a:off x="5486400" y="1325880"/>
-            <a:ext cx="347472" cy="347472"/>
-          </a:xfrm>
-          <a:prstGeom prst="rect">
-            <a:avLst/>
-          </a:prstGeom>
-          <a:noFill/>
-          <a:ln/>
-        </p:spPr>
-        <p:txBody>
-          <a:bodyPr wrap="square" lIns="0" tIns="0" rIns="0" bIns="0" rtlCol="0" anchor="ctr"/>
-          <a:lstStyle/>
-          <a:p>
-            <a:pPr algn="ctr" indent="0" marL="0">
-              <a:buNone/>
-            </a:pPr>
-            <a:r>
-              <a:rPr lang="en-US" sz="1400" b="1" dirty="0">
-                <a:solidFill>
-                  <a:srgbClr val="161B22"/>
-                </a:solidFill>
-                <a:latin typeface="Arial" pitchFamily="34" charset="0"/>
-                <a:ea typeface="Arial" pitchFamily="34" charset="-122"/>
-                <a:cs typeface="Arial" pitchFamily="34" charset="-120"/>
-              </a:rPr>
-              <a:t>1</a:t>
-            </a:r>
-            <a:endParaRPr lang="en-US" sz="1400" dirty="0"/>
-          </a:p>
-        </p:txBody>
-      </p:sp>
-      <p:sp>
-        <p:nvSpPr>
-          <p:cNvPr id="7" name="Text 4"/>
-          <p:cNvSpPr txBox="1"/>
-          <p:nvPr/>
-        </p:nvSpPr>
-        <p:spPr>
-          <a:xfrm>
-            <a:off x="5989320" y="1307592"/>
-            <a:ext cx="2834640" cy="320040"/>
-          </a:xfrm>
-          <a:prstGeom prst="rect">
-            <a:avLst/>
-          </a:prstGeom>
-          <a:noFill/>
-          <a:ln/>
-        </p:spPr>
-        <p:txBody>
-          <a:bodyPr wrap="square" lIns="0" tIns="0" rIns="0" bIns="0" rtlCol="0" anchor="ctr"/>
-          <a:lstStyle/>
+              <a:t>Hand-off</a:t>
+            </a:r>
+            <a:endParaRPr lang="en-US" sz="1600" dirty="0"/>
+          </a:p>
           <a:p>
             <a:pPr indent="0" marL="0">
               <a:buNone/>
             </a:pPr>
             <a:r>
-              <a:rPr lang="en-US" sz="1400" b="1" dirty="0">
-                <a:solidFill>
-                  <a:srgbClr val="FFFFFF"/>
-                </a:solidFill>
-                <a:latin typeface="Arial" pitchFamily="34" charset="0"/>
-                <a:ea typeface="Arial" pitchFamily="34" charset="-122"/>
-                <a:cs typeface="Arial" pitchFamily="34" charset="-120"/>
-              </a:rPr>
-              <a:t>A teacher must be consistent</a:t>
-            </a:r>
-            <a:endParaRPr lang="en-US" sz="1400" dirty="0"/>
-          </a:p>
-        </p:txBody>
-      </p:sp>
-      <p:sp>
-        <p:nvSpPr>
-          <p:cNvPr id="8" name="Text 5"/>
-          <p:cNvSpPr txBox="1"/>
-          <p:nvPr/>
-        </p:nvSpPr>
-        <p:spPr>
-          <a:xfrm>
-            <a:off x="5989320" y="1627632"/>
-            <a:ext cx="2834640" cy="685800"/>
-          </a:xfrm>
-          <a:prstGeom prst="rect">
-            <a:avLst/>
-          </a:prstGeom>
-          <a:noFill/>
-          <a:ln/>
-        </p:spPr>
-        <p:txBody>
-          <a:bodyPr wrap="square" lIns="0" tIns="0" rIns="0" bIns="0" rtlCol="0" anchor="t"/>
-          <a:lstStyle/>
-          <a:p>
-            <a:pPr indent="0" marL="0">
-              <a:buNone/>
-            </a:pPr>
-            <a:r>
-              <a:rPr lang="en-US" sz="1200" dirty="0">
+              <a:rPr lang="en-US" sz="1300" dirty="0">
                 <a:solidFill>
                   <a:srgbClr val="9AA7B5"/>
                 </a:solidFill>
@@ -4175,47 +4600,70 @@
                 <a:ea typeface="Calibri" pitchFamily="34" charset="-122"/>
                 <a:cs typeface="Calibri" pitchFamily="34" charset="-120"/>
               </a:rPr>
-              <a:t>picking the best of 12 grip angles looked random to the student — one fixed rule</a:t>
-            </a:r>
-            <a:endParaRPr lang="en-US" sz="1200" dirty="0"/>
-          </a:p>
-        </p:txBody>
-      </p:sp>
-      <p:sp>
-        <p:nvSpPr>
-          <p:cNvPr id="9" name="Shape 6"/>
-          <p:cNvSpPr/>
-          <p:nvPr/>
-        </p:nvSpPr>
-        <p:spPr>
-          <a:xfrm>
-            <a:off x="5486400" y="2514600"/>
-            <a:ext cx="347472" cy="347472"/>
-          </a:xfrm>
-          <a:prstGeom prst="ellipse">
-            <a:avLst/>
-          </a:prstGeom>
-          <a:solidFill>
-            <a:srgbClr val="E8B923"/>
-          </a:solidFill>
-          <a:ln w="12700">
-            <a:solidFill>
-              <a:srgbClr val="E8B923"/>
-            </a:solidFill>
-            <a:prstDash val="solid"/>
-          </a:ln>
-        </p:spPr>
-      </p:sp>
-      <p:sp>
-        <p:nvSpPr>
-          <p:cNvPr id="10" name="Text 7"/>
-          <p:cNvSpPr txBox="1"/>
-          <p:nvPr/>
-        </p:nvSpPr>
-        <p:spPr>
-          <a:xfrm>
-            <a:off x="5486400" y="2514600"/>
-            <a:ext cx="347472" cy="347472"/>
+              <a:t>The fork starts on arm B's side but belongs on arm A's. B carries it in, A moves up at the same time, lines up 1.5 mm away, grips, then B lets go.</a:t>
+            </a:r>
+            <a:endParaRPr lang="en-US" sz="1600" dirty="0"/>
+          </a:p>
+        </p:txBody>
+      </p:sp>
+      <p:pic>
+        <p:nvPicPr>
+          <p:cNvPr id="5" name="Image 1" descr="C:\DriveSync\Creative\hackathons\ai-infra-summit-2026\submission\img\recovery_bumped.png">    </p:cNvPr>
+          <p:cNvPicPr>
+            <a:picLocks noChangeAspect="1"/>
+          </p:cNvPicPr>
+          <p:nvPr/>
+        </p:nvPicPr>
+        <p:blipFill>
+          <a:blip r:embed="rId2"/>
+          <a:stretch>
+            <a:fillRect/>
+          </a:stretch>
+        </p:blipFill>
+        <p:spPr>
+          <a:xfrm>
+            <a:off x="4754880" y="1188720"/>
+            <a:ext cx="1920240" cy="1444752"/>
+          </a:xfrm>
+          <a:prstGeom prst="rect">
+            <a:avLst/>
+          </a:prstGeom>
+        </p:spPr>
+      </p:pic>
+      <p:pic>
+        <p:nvPicPr>
+          <p:cNvPr id="6" name="Image 2" descr="C:\DriveSync\Creative\hackathons\ai-infra-summit-2026\submission\img\recovery_fixed.png">    </p:cNvPr>
+          <p:cNvPicPr>
+            <a:picLocks noChangeAspect="1"/>
+          </p:cNvPicPr>
+          <p:nvPr/>
+        </p:nvPicPr>
+        <p:blipFill>
+          <a:blip r:embed="rId3"/>
+          <a:stretch>
+            <a:fillRect/>
+          </a:stretch>
+        </p:blipFill>
+        <p:spPr>
+          <a:xfrm>
+            <a:off x="6766560" y="1188720"/>
+            <a:ext cx="1920240" cy="1444752"/>
+          </a:xfrm>
+          <a:prstGeom prst="rect">
+            <a:avLst/>
+          </a:prstGeom>
+        </p:spPr>
+      </p:pic>
+      <p:sp>
+        <p:nvSpPr>
+          <p:cNvPr id="7" name="Text 2"/>
+          <p:cNvSpPr txBox="1"/>
+          <p:nvPr/>
+        </p:nvSpPr>
+        <p:spPr>
+          <a:xfrm>
+            <a:off x="4754880" y="2670048"/>
+            <a:ext cx="1920240" cy="274320"/>
           </a:xfrm>
           <a:prstGeom prst="rect">
             <a:avLst/>
@@ -4231,93 +4679,15 @@
               <a:buNone/>
             </a:pPr>
             <a:r>
-              <a:rPr lang="en-US" sz="1400" b="1" dirty="0">
-                <a:solidFill>
-                  <a:srgbClr val="161B22"/>
-                </a:solidFill>
-                <a:latin typeface="Arial" pitchFamily="34" charset="0"/>
-                <a:ea typeface="Arial" pitchFamily="34" charset="-122"/>
-                <a:cs typeface="Arial" pitchFamily="34" charset="-120"/>
-              </a:rPr>
-              <a:t>2</a:t>
-            </a:r>
-            <a:endParaRPr lang="en-US" sz="1400" dirty="0"/>
-          </a:p>
-        </p:txBody>
-      </p:sp>
-      <p:sp>
-        <p:nvSpPr>
-          <p:cNvPr id="11" name="Text 8"/>
-          <p:cNvSpPr txBox="1"/>
-          <p:nvPr/>
-        </p:nvSpPr>
-        <p:spPr>
-          <a:xfrm>
-            <a:off x="5989320" y="2496312"/>
-            <a:ext cx="2834640" cy="320040"/>
-          </a:xfrm>
-          <a:prstGeom prst="rect">
-            <a:avLst/>
-          </a:prstGeom>
-          <a:noFill/>
-          <a:ln/>
-        </p:spPr>
-        <p:txBody>
-          <a:bodyPr wrap="square" lIns="0" tIns="0" rIns="0" bIns="0" rtlCol="0" anchor="ctr"/>
-          <a:lstStyle/>
-          <a:p>
-            <a:pPr indent="0" marL="0">
-              <a:buNone/>
-            </a:pPr>
-            <a:r>
-              <a:rPr lang="en-US" sz="1400" b="1" dirty="0">
-                <a:solidFill>
-                  <a:srgbClr val="FFFFFF"/>
-                </a:solidFill>
-                <a:latin typeface="Arial" pitchFamily="34" charset="0"/>
-                <a:ea typeface="Arial" pitchFamily="34" charset="-122"/>
-                <a:cs typeface="Arial" pitchFamily="34" charset="-120"/>
-              </a:rPr>
-              <a:t>Targets, not small moves</a:t>
-            </a:r>
-            <a:endParaRPr lang="en-US" sz="1400" dirty="0"/>
-          </a:p>
-        </p:txBody>
-      </p:sp>
-      <p:sp>
-        <p:nvSpPr>
-          <p:cNvPr id="12" name="Text 9"/>
-          <p:cNvSpPr txBox="1"/>
-          <p:nvPr/>
-        </p:nvSpPr>
-        <p:spPr>
-          <a:xfrm>
-            <a:off x="5989320" y="2816352"/>
-            <a:ext cx="2834640" cy="685800"/>
-          </a:xfrm>
-          <a:prstGeom prst="rect">
-            <a:avLst/>
-          </a:prstGeom>
-          <a:noFill/>
-          <a:ln/>
-        </p:spPr>
-        <p:txBody>
-          <a:bodyPr wrap="square" lIns="0" tIns="0" rIns="0" bIns="0" rtlCol="0" anchor="t"/>
-          <a:lstStyle/>
-          <a:p>
-            <a:pPr indent="0" marL="0">
-              <a:buNone/>
-            </a:pPr>
-            <a:r>
               <a:rPr lang="en-US" sz="1200" dirty="0">
                 <a:solidFill>
-                  <a:srgbClr val="9AA7B5"/>
+                  <a:srgbClr val="F87171"/>
                 </a:solidFill>
                 <a:latin typeface="Calibri" pitchFamily="34" charset="0"/>
                 <a:ea typeface="Calibri" pitchFamily="34" charset="-122"/>
                 <a:cs typeface="Calibri" pitchFamily="34" charset="-120"/>
               </a:rPr>
-              <a:t>tiny per-step errors added up to centimetres</a:t>
+              <a:t>knocked</a:t>
             </a:r>
             <a:endParaRPr lang="en-US" sz="1200" dirty="0"/>
           </a:p>
@@ -4325,39 +4695,14 @@
       </p:sp>
       <p:sp>
         <p:nvSpPr>
-          <p:cNvPr id="13" name="Shape 10"/>
-          <p:cNvSpPr/>
-          <p:nvPr/>
-        </p:nvSpPr>
-        <p:spPr>
-          <a:xfrm>
-            <a:off x="5486400" y="3703320"/>
-            <a:ext cx="347472" cy="347472"/>
-          </a:xfrm>
-          <a:prstGeom prst="ellipse">
-            <a:avLst/>
-          </a:prstGeom>
-          <a:solidFill>
-            <a:srgbClr val="E8B923"/>
-          </a:solidFill>
-          <a:ln w="12700">
-            <a:solidFill>
-              <a:srgbClr val="E8B923"/>
-            </a:solidFill>
-            <a:prstDash val="solid"/>
-          </a:ln>
-        </p:spPr>
-      </p:sp>
-      <p:sp>
-        <p:nvSpPr>
-          <p:cNvPr id="14" name="Text 11"/>
-          <p:cNvSpPr txBox="1"/>
-          <p:nvPr/>
-        </p:nvSpPr>
-        <p:spPr>
-          <a:xfrm>
-            <a:off x="5486400" y="3703320"/>
-            <a:ext cx="347472" cy="347472"/>
+          <p:cNvPr id="8" name="Text 3"/>
+          <p:cNvSpPr txBox="1"/>
+          <p:nvPr/>
+        </p:nvSpPr>
+        <p:spPr>
+          <a:xfrm>
+            <a:off x="6766560" y="2670048"/>
+            <a:ext cx="1920240" cy="274320"/>
           </a:xfrm>
           <a:prstGeom prst="rect">
             <a:avLst/>
@@ -4373,95 +4718,73 @@
               <a:buNone/>
             </a:pPr>
             <a:r>
-              <a:rPr lang="en-US" sz="1400" b="1" dirty="0">
-                <a:solidFill>
-                  <a:srgbClr val="161B22"/>
-                </a:solidFill>
-                <a:latin typeface="Arial" pitchFamily="34" charset="0"/>
-                <a:ea typeface="Arial" pitchFamily="34" charset="-122"/>
-                <a:cs typeface="Arial" pitchFamily="34" charset="-120"/>
-              </a:rPr>
-              <a:t>3</a:t>
-            </a:r>
-            <a:endParaRPr lang="en-US" sz="1400" dirty="0"/>
-          </a:p>
-        </p:txBody>
-      </p:sp>
-      <p:sp>
-        <p:nvSpPr>
-          <p:cNvPr id="15" name="Text 12"/>
-          <p:cNvSpPr txBox="1"/>
-          <p:nvPr/>
-        </p:nvSpPr>
-        <p:spPr>
-          <a:xfrm>
-            <a:off x="5989320" y="3685032"/>
-            <a:ext cx="2834640" cy="320040"/>
-          </a:xfrm>
-          <a:prstGeom prst="rect">
-            <a:avLst/>
-          </a:prstGeom>
-          <a:noFill/>
-          <a:ln/>
-        </p:spPr>
-        <p:txBody>
-          <a:bodyPr wrap="square" lIns="0" tIns="0" rIns="0" bIns="0" rtlCol="0" anchor="ctr"/>
-          <a:lstStyle/>
-          <a:p>
-            <a:pPr indent="0" marL="0">
-              <a:buNone/>
-            </a:pPr>
-            <a:r>
-              <a:rPr lang="en-US" sz="1400" b="1" dirty="0">
-                <a:solidFill>
-                  <a:srgbClr val="FFFFFF"/>
-                </a:solidFill>
-                <a:latin typeface="Arial" pitchFamily="34" charset="0"/>
-                <a:ea typeface="Arial" pitchFamily="34" charset="-122"/>
-                <a:cs typeface="Arial" pitchFamily="34" charset="-120"/>
-              </a:rPr>
-              <a:t>Think in the mug's frame</a:t>
-            </a:r>
-            <a:endParaRPr lang="en-US" sz="1400" dirty="0"/>
-          </a:p>
-        </p:txBody>
-      </p:sp>
-      <p:sp>
-        <p:nvSpPr>
-          <p:cNvPr id="16" name="Text 13"/>
-          <p:cNvSpPr txBox="1"/>
-          <p:nvPr/>
-        </p:nvSpPr>
-        <p:spPr>
-          <a:xfrm>
-            <a:off x="5989320" y="4005072"/>
-            <a:ext cx="2834640" cy="685800"/>
-          </a:xfrm>
-          <a:prstGeom prst="rect">
-            <a:avLst/>
-          </a:prstGeom>
-          <a:noFill/>
-          <a:ln/>
-        </p:spPr>
-        <p:txBody>
-          <a:bodyPr wrap="square" lIns="0" tIns="0" rIns="0" bIns="0" rtlCol="0" anchor="t"/>
-          <a:lstStyle/>
-          <a:p>
-            <a:pPr indent="0" marL="0">
-              <a:buNone/>
-            </a:pPr>
-            <a:r>
               <a:rPr lang="en-US" sz="1200" dirty="0">
                 <a:solidFill>
-                  <a:srgbClr val="9AA7B5"/>
+                  <a:srgbClr val="4ADE80"/>
                 </a:solidFill>
                 <a:latin typeface="Calibri" pitchFamily="34" charset="0"/>
                 <a:ea typeface="Calibri" pitchFamily="34" charset="-122"/>
                 <a:cs typeface="Calibri" pitchFamily="34" charset="-120"/>
               </a:rPr>
-              <a:t>"grip beside the mug" becomes the same move every time</a:t>
+              <a:t>seen and fixed</a:t>
             </a:r>
             <a:endParaRPr lang="en-US" sz="1200" dirty="0"/>
+          </a:p>
+        </p:txBody>
+      </p:sp>
+      <p:sp>
+        <p:nvSpPr>
+          <p:cNvPr id="9" name="Text 4"/>
+          <p:cNvSpPr txBox="1"/>
+          <p:nvPr/>
+        </p:nvSpPr>
+        <p:spPr>
+          <a:xfrm>
+            <a:off x="4754880" y="3063240"/>
+            <a:ext cx="3931920" cy="1463040"/>
+          </a:xfrm>
+          <a:prstGeom prst="rect">
+            <a:avLst/>
+          </a:prstGeom>
+          <a:noFill/>
+          <a:ln/>
+        </p:spPr>
+        <p:txBody>
+          <a:bodyPr wrap="square" lIns="0" tIns="0" rIns="0" bIns="0" rtlCol="0" anchor="t"/>
+          <a:lstStyle/>
+          <a:p>
+            <a:pPr indent="0" marL="0">
+              <a:buNone/>
+            </a:pPr>
+            <a:r>
+              <a:rPr lang="en-US" sz="1600" b="1" dirty="0">
+                <a:solidFill>
+                  <a:srgbClr val="FFFFFF"/>
+                </a:solidFill>
+                <a:latin typeface="Calibri" pitchFamily="34" charset="0"/>
+                <a:ea typeface="Calibri" pitchFamily="34" charset="-122"/>
+                <a:cs typeface="Calibri" pitchFamily="34" charset="-120"/>
+              </a:rPr>
+              <a:t>Recovery</a:t>
+            </a:r>
+            <a:endParaRPr lang="en-US" sz="1600" dirty="0"/>
+          </a:p>
+          <a:p>
+            <a:pPr indent="0" marL="0">
+              <a:buNone/>
+            </a:pPr>
+            <a:r>
+              <a:rPr lang="en-US" sz="1300" dirty="0">
+                <a:solidFill>
+                  <a:srgbClr val="9AA7B5"/>
+                </a:solidFill>
+                <a:latin typeface="Calibri" pitchFamily="34" charset="0"/>
+                <a:ea typeface="Calibri" pitchFamily="34" charset="-122"/>
+                <a:cs typeface="Calibri" pitchFamily="34" charset="-120"/>
+              </a:rPr>
+              <a:t>Mid-task, the plate is knocked 6 cm. After the next item the robot looks at everything it already placed, sees the plate has moved, and puts it back before carrying on.</a:t>
+            </a:r>
+            <a:endParaRPr lang="en-US" sz="1600" dirty="0"/>
           </a:p>
         </p:txBody>
       </p:sp>
@@ -4530,6 +4853,558 @@
                 <a:ea typeface="Arial" pitchFamily="34" charset="-122"/>
                 <a:cs typeface="Arial" pitchFamily="34" charset="-120"/>
               </a:rPr>
+              <a:t>Our own teacher trained the policy</a:t>
+            </a:r>
+            <a:endParaRPr lang="en-US" sz="3000" dirty="0"/>
+          </a:p>
+        </p:txBody>
+      </p:sp>
+      <p:sp>
+        <p:nvSpPr>
+          <p:cNvPr id="3" name="Text 1"/>
+          <p:cNvSpPr txBox="1"/>
+          <p:nvPr/>
+        </p:nvSpPr>
+        <p:spPr>
+          <a:xfrm>
+            <a:off x="457200" y="804672"/>
+            <a:ext cx="8229600" cy="320040"/>
+          </a:xfrm>
+          <a:prstGeom prst="rect">
+            <a:avLst/>
+          </a:prstGeom>
+          <a:noFill/>
+          <a:ln/>
+        </p:spPr>
+        <p:txBody>
+          <a:bodyPr wrap="square" lIns="0" tIns="0" rIns="0" bIns="0" rtlCol="0" anchor="ctr"/>
+          <a:lstStyle/>
+          <a:p>
+            <a:pPr indent="0" marL="0">
+              <a:buNone/>
+            </a:pPr>
+            <a:r>
+              <a:rPr lang="en-US" sz="1400" dirty="0">
+                <a:solidFill>
+                  <a:srgbClr val="9AA7B5"/>
+                </a:solidFill>
+                <a:latin typeface="Calibri" pitchFamily="34" charset="0"/>
+                <a:ea typeface="Calibri" pitchFamily="34" charset="-122"/>
+                <a:cs typeface="Calibri" pitchFamily="34" charset="-120"/>
+              </a:rPr>
+              <a:t>LeRobot ACT on a laptop CPU · 1,219 demonstrations recorded automatically · success on unseen tables</a:t>
+            </a:r>
+            <a:endParaRPr lang="en-US" sz="1400" dirty="0"/>
+          </a:p>
+        </p:txBody>
+      </p:sp>
+      <p:graphicFrame>
+        <p:nvGraphicFramePr>
+          <p:cNvPr id="4" name="Chart 0" descr=""/>
+          <p:cNvGraphicFramePr/>
+          <p:nvPr/>
+        </p:nvGraphicFramePr>
+        <p:xfrm>
+          <a:off x="365760" y="1234440"/>
+          <a:ext cx="4846320" cy="3566160"/>
+        </p:xfrm>
+        <a:graphic xmlns:a="http://schemas.openxmlformats.org/drawingml/2006/main">
+          <a:graphicData uri="http://schemas.openxmlformats.org/drawingml/2006/chart">
+            <c:chart xmlns:c="http://schemas.openxmlformats.org/drawingml/2006/chart" r:id="rId1"/>
+          </a:graphicData>
+        </a:graphic>
+      </p:graphicFrame>
+      <p:sp>
+        <p:nvSpPr>
+          <p:cNvPr id="5" name="Shape 2"/>
+          <p:cNvSpPr/>
+          <p:nvPr/>
+        </p:nvSpPr>
+        <p:spPr>
+          <a:xfrm>
+            <a:off x="5486400" y="1325880"/>
+            <a:ext cx="347472" cy="347472"/>
+          </a:xfrm>
+          <a:prstGeom prst="ellipse">
+            <a:avLst/>
+          </a:prstGeom>
+          <a:solidFill>
+            <a:srgbClr val="E8B923"/>
+          </a:solidFill>
+          <a:ln w="12700">
+            <a:solidFill>
+              <a:srgbClr val="E8B923"/>
+            </a:solidFill>
+            <a:prstDash val="solid"/>
+          </a:ln>
+        </p:spPr>
+      </p:sp>
+      <p:sp>
+        <p:nvSpPr>
+          <p:cNvPr id="6" name="Text 3"/>
+          <p:cNvSpPr txBox="1"/>
+          <p:nvPr/>
+        </p:nvSpPr>
+        <p:spPr>
+          <a:xfrm>
+            <a:off x="5486400" y="1325880"/>
+            <a:ext cx="347472" cy="347472"/>
+          </a:xfrm>
+          <a:prstGeom prst="rect">
+            <a:avLst/>
+          </a:prstGeom>
+          <a:noFill/>
+          <a:ln/>
+        </p:spPr>
+        <p:txBody>
+          <a:bodyPr wrap="square" lIns="0" tIns="0" rIns="0" bIns="0" rtlCol="0" anchor="ctr"/>
+          <a:lstStyle/>
+          <a:p>
+            <a:pPr algn="ctr" indent="0" marL="0">
+              <a:buNone/>
+            </a:pPr>
+            <a:r>
+              <a:rPr lang="en-US" sz="1400" b="1" dirty="0">
+                <a:solidFill>
+                  <a:srgbClr val="161B22"/>
+                </a:solidFill>
+                <a:latin typeface="Arial" pitchFamily="34" charset="0"/>
+                <a:ea typeface="Arial" pitchFamily="34" charset="-122"/>
+                <a:cs typeface="Arial" pitchFamily="34" charset="-120"/>
+              </a:rPr>
+              <a:t>1</a:t>
+            </a:r>
+            <a:endParaRPr lang="en-US" sz="1400" dirty="0"/>
+          </a:p>
+        </p:txBody>
+      </p:sp>
+      <p:sp>
+        <p:nvSpPr>
+          <p:cNvPr id="7" name="Text 4"/>
+          <p:cNvSpPr txBox="1"/>
+          <p:nvPr/>
+        </p:nvSpPr>
+        <p:spPr>
+          <a:xfrm>
+            <a:off x="5989320" y="1307592"/>
+            <a:ext cx="2834640" cy="320040"/>
+          </a:xfrm>
+          <a:prstGeom prst="rect">
+            <a:avLst/>
+          </a:prstGeom>
+          <a:noFill/>
+          <a:ln/>
+        </p:spPr>
+        <p:txBody>
+          <a:bodyPr wrap="square" lIns="0" tIns="0" rIns="0" bIns="0" rtlCol="0" anchor="ctr"/>
+          <a:lstStyle/>
+          <a:p>
+            <a:pPr indent="0" marL="0">
+              <a:buNone/>
+            </a:pPr>
+            <a:r>
+              <a:rPr lang="en-US" sz="1400" b="1" dirty="0">
+                <a:solidFill>
+                  <a:srgbClr val="FFFFFF"/>
+                </a:solidFill>
+                <a:latin typeface="Arial" pitchFamily="34" charset="0"/>
+                <a:ea typeface="Arial" pitchFamily="34" charset="-122"/>
+                <a:cs typeface="Arial" pitchFamily="34" charset="-120"/>
+              </a:rPr>
+              <a:t>A teacher must be consistent</a:t>
+            </a:r>
+            <a:endParaRPr lang="en-US" sz="1400" dirty="0"/>
+          </a:p>
+        </p:txBody>
+      </p:sp>
+      <p:sp>
+        <p:nvSpPr>
+          <p:cNvPr id="8" name="Text 5"/>
+          <p:cNvSpPr txBox="1"/>
+          <p:nvPr/>
+        </p:nvSpPr>
+        <p:spPr>
+          <a:xfrm>
+            <a:off x="5989320" y="1627632"/>
+            <a:ext cx="2834640" cy="685800"/>
+          </a:xfrm>
+          <a:prstGeom prst="rect">
+            <a:avLst/>
+          </a:prstGeom>
+          <a:noFill/>
+          <a:ln/>
+        </p:spPr>
+        <p:txBody>
+          <a:bodyPr wrap="square" lIns="0" tIns="0" rIns="0" bIns="0" rtlCol="0" anchor="t"/>
+          <a:lstStyle/>
+          <a:p>
+            <a:pPr indent="0" marL="0">
+              <a:buNone/>
+            </a:pPr>
+            <a:r>
+              <a:rPr lang="en-US" sz="1200" dirty="0">
+                <a:solidFill>
+                  <a:srgbClr val="9AA7B5"/>
+                </a:solidFill>
+                <a:latin typeface="Calibri" pitchFamily="34" charset="0"/>
+                <a:ea typeface="Calibri" pitchFamily="34" charset="-122"/>
+                <a:cs typeface="Calibri" pitchFamily="34" charset="-120"/>
+              </a:rPr>
+              <a:t>picking the best of 12 grip angles looked random to the student — one fixed rule</a:t>
+            </a:r>
+            <a:endParaRPr lang="en-US" sz="1200" dirty="0"/>
+          </a:p>
+        </p:txBody>
+      </p:sp>
+      <p:sp>
+        <p:nvSpPr>
+          <p:cNvPr id="9" name="Shape 6"/>
+          <p:cNvSpPr/>
+          <p:nvPr/>
+        </p:nvSpPr>
+        <p:spPr>
+          <a:xfrm>
+            <a:off x="5486400" y="2514600"/>
+            <a:ext cx="347472" cy="347472"/>
+          </a:xfrm>
+          <a:prstGeom prst="ellipse">
+            <a:avLst/>
+          </a:prstGeom>
+          <a:solidFill>
+            <a:srgbClr val="E8B923"/>
+          </a:solidFill>
+          <a:ln w="12700">
+            <a:solidFill>
+              <a:srgbClr val="E8B923"/>
+            </a:solidFill>
+            <a:prstDash val="solid"/>
+          </a:ln>
+        </p:spPr>
+      </p:sp>
+      <p:sp>
+        <p:nvSpPr>
+          <p:cNvPr id="10" name="Text 7"/>
+          <p:cNvSpPr txBox="1"/>
+          <p:nvPr/>
+        </p:nvSpPr>
+        <p:spPr>
+          <a:xfrm>
+            <a:off x="5486400" y="2514600"/>
+            <a:ext cx="347472" cy="347472"/>
+          </a:xfrm>
+          <a:prstGeom prst="rect">
+            <a:avLst/>
+          </a:prstGeom>
+          <a:noFill/>
+          <a:ln/>
+        </p:spPr>
+        <p:txBody>
+          <a:bodyPr wrap="square" lIns="0" tIns="0" rIns="0" bIns="0" rtlCol="0" anchor="ctr"/>
+          <a:lstStyle/>
+          <a:p>
+            <a:pPr algn="ctr" indent="0" marL="0">
+              <a:buNone/>
+            </a:pPr>
+            <a:r>
+              <a:rPr lang="en-US" sz="1400" b="1" dirty="0">
+                <a:solidFill>
+                  <a:srgbClr val="161B22"/>
+                </a:solidFill>
+                <a:latin typeface="Arial" pitchFamily="34" charset="0"/>
+                <a:ea typeface="Arial" pitchFamily="34" charset="-122"/>
+                <a:cs typeface="Arial" pitchFamily="34" charset="-120"/>
+              </a:rPr>
+              <a:t>2</a:t>
+            </a:r>
+            <a:endParaRPr lang="en-US" sz="1400" dirty="0"/>
+          </a:p>
+        </p:txBody>
+      </p:sp>
+      <p:sp>
+        <p:nvSpPr>
+          <p:cNvPr id="11" name="Text 8"/>
+          <p:cNvSpPr txBox="1"/>
+          <p:nvPr/>
+        </p:nvSpPr>
+        <p:spPr>
+          <a:xfrm>
+            <a:off x="5989320" y="2496312"/>
+            <a:ext cx="2834640" cy="320040"/>
+          </a:xfrm>
+          <a:prstGeom prst="rect">
+            <a:avLst/>
+          </a:prstGeom>
+          <a:noFill/>
+          <a:ln/>
+        </p:spPr>
+        <p:txBody>
+          <a:bodyPr wrap="square" lIns="0" tIns="0" rIns="0" bIns="0" rtlCol="0" anchor="ctr"/>
+          <a:lstStyle/>
+          <a:p>
+            <a:pPr indent="0" marL="0">
+              <a:buNone/>
+            </a:pPr>
+            <a:r>
+              <a:rPr lang="en-US" sz="1400" b="1" dirty="0">
+                <a:solidFill>
+                  <a:srgbClr val="FFFFFF"/>
+                </a:solidFill>
+                <a:latin typeface="Arial" pitchFamily="34" charset="0"/>
+                <a:ea typeface="Arial" pitchFamily="34" charset="-122"/>
+                <a:cs typeface="Arial" pitchFamily="34" charset="-120"/>
+              </a:rPr>
+              <a:t>Targets, not small moves</a:t>
+            </a:r>
+            <a:endParaRPr lang="en-US" sz="1400" dirty="0"/>
+          </a:p>
+        </p:txBody>
+      </p:sp>
+      <p:sp>
+        <p:nvSpPr>
+          <p:cNvPr id="12" name="Text 9"/>
+          <p:cNvSpPr txBox="1"/>
+          <p:nvPr/>
+        </p:nvSpPr>
+        <p:spPr>
+          <a:xfrm>
+            <a:off x="5989320" y="2816352"/>
+            <a:ext cx="2834640" cy="685800"/>
+          </a:xfrm>
+          <a:prstGeom prst="rect">
+            <a:avLst/>
+          </a:prstGeom>
+          <a:noFill/>
+          <a:ln/>
+        </p:spPr>
+        <p:txBody>
+          <a:bodyPr wrap="square" lIns="0" tIns="0" rIns="0" bIns="0" rtlCol="0" anchor="t"/>
+          <a:lstStyle/>
+          <a:p>
+            <a:pPr indent="0" marL="0">
+              <a:buNone/>
+            </a:pPr>
+            <a:r>
+              <a:rPr lang="en-US" sz="1200" dirty="0">
+                <a:solidFill>
+                  <a:srgbClr val="9AA7B5"/>
+                </a:solidFill>
+                <a:latin typeface="Calibri" pitchFamily="34" charset="0"/>
+                <a:ea typeface="Calibri" pitchFamily="34" charset="-122"/>
+                <a:cs typeface="Calibri" pitchFamily="34" charset="-120"/>
+              </a:rPr>
+              <a:t>tiny per-step errors added up to centimetres</a:t>
+            </a:r>
+            <a:endParaRPr lang="en-US" sz="1200" dirty="0"/>
+          </a:p>
+        </p:txBody>
+      </p:sp>
+      <p:sp>
+        <p:nvSpPr>
+          <p:cNvPr id="13" name="Shape 10"/>
+          <p:cNvSpPr/>
+          <p:nvPr/>
+        </p:nvSpPr>
+        <p:spPr>
+          <a:xfrm>
+            <a:off x="5486400" y="3703320"/>
+            <a:ext cx="347472" cy="347472"/>
+          </a:xfrm>
+          <a:prstGeom prst="ellipse">
+            <a:avLst/>
+          </a:prstGeom>
+          <a:solidFill>
+            <a:srgbClr val="E8B923"/>
+          </a:solidFill>
+          <a:ln w="12700">
+            <a:solidFill>
+              <a:srgbClr val="E8B923"/>
+            </a:solidFill>
+            <a:prstDash val="solid"/>
+          </a:ln>
+        </p:spPr>
+      </p:sp>
+      <p:sp>
+        <p:nvSpPr>
+          <p:cNvPr id="14" name="Text 11"/>
+          <p:cNvSpPr txBox="1"/>
+          <p:nvPr/>
+        </p:nvSpPr>
+        <p:spPr>
+          <a:xfrm>
+            <a:off x="5486400" y="3703320"/>
+            <a:ext cx="347472" cy="347472"/>
+          </a:xfrm>
+          <a:prstGeom prst="rect">
+            <a:avLst/>
+          </a:prstGeom>
+          <a:noFill/>
+          <a:ln/>
+        </p:spPr>
+        <p:txBody>
+          <a:bodyPr wrap="square" lIns="0" tIns="0" rIns="0" bIns="0" rtlCol="0" anchor="ctr"/>
+          <a:lstStyle/>
+          <a:p>
+            <a:pPr algn="ctr" indent="0" marL="0">
+              <a:buNone/>
+            </a:pPr>
+            <a:r>
+              <a:rPr lang="en-US" sz="1400" b="1" dirty="0">
+                <a:solidFill>
+                  <a:srgbClr val="161B22"/>
+                </a:solidFill>
+                <a:latin typeface="Arial" pitchFamily="34" charset="0"/>
+                <a:ea typeface="Arial" pitchFamily="34" charset="-122"/>
+                <a:cs typeface="Arial" pitchFamily="34" charset="-120"/>
+              </a:rPr>
+              <a:t>3</a:t>
+            </a:r>
+            <a:endParaRPr lang="en-US" sz="1400" dirty="0"/>
+          </a:p>
+        </p:txBody>
+      </p:sp>
+      <p:sp>
+        <p:nvSpPr>
+          <p:cNvPr id="15" name="Text 12"/>
+          <p:cNvSpPr txBox="1"/>
+          <p:nvPr/>
+        </p:nvSpPr>
+        <p:spPr>
+          <a:xfrm>
+            <a:off x="5989320" y="3685032"/>
+            <a:ext cx="2834640" cy="320040"/>
+          </a:xfrm>
+          <a:prstGeom prst="rect">
+            <a:avLst/>
+          </a:prstGeom>
+          <a:noFill/>
+          <a:ln/>
+        </p:spPr>
+        <p:txBody>
+          <a:bodyPr wrap="square" lIns="0" tIns="0" rIns="0" bIns="0" rtlCol="0" anchor="ctr"/>
+          <a:lstStyle/>
+          <a:p>
+            <a:pPr indent="0" marL="0">
+              <a:buNone/>
+            </a:pPr>
+            <a:r>
+              <a:rPr lang="en-US" sz="1400" b="1" dirty="0">
+                <a:solidFill>
+                  <a:srgbClr val="FFFFFF"/>
+                </a:solidFill>
+                <a:latin typeface="Arial" pitchFamily="34" charset="0"/>
+                <a:ea typeface="Arial" pitchFamily="34" charset="-122"/>
+                <a:cs typeface="Arial" pitchFamily="34" charset="-120"/>
+              </a:rPr>
+              <a:t>Think in the mug's frame</a:t>
+            </a:r>
+            <a:endParaRPr lang="en-US" sz="1400" dirty="0"/>
+          </a:p>
+        </p:txBody>
+      </p:sp>
+      <p:sp>
+        <p:nvSpPr>
+          <p:cNvPr id="16" name="Text 13"/>
+          <p:cNvSpPr txBox="1"/>
+          <p:nvPr/>
+        </p:nvSpPr>
+        <p:spPr>
+          <a:xfrm>
+            <a:off x="5989320" y="4005072"/>
+            <a:ext cx="2834640" cy="685800"/>
+          </a:xfrm>
+          <a:prstGeom prst="rect">
+            <a:avLst/>
+          </a:prstGeom>
+          <a:noFill/>
+          <a:ln/>
+        </p:spPr>
+        <p:txBody>
+          <a:bodyPr wrap="square" lIns="0" tIns="0" rIns="0" bIns="0" rtlCol="0" anchor="t"/>
+          <a:lstStyle/>
+          <a:p>
+            <a:pPr indent="0" marL="0">
+              <a:buNone/>
+            </a:pPr>
+            <a:r>
+              <a:rPr lang="en-US" sz="1200" dirty="0">
+                <a:solidFill>
+                  <a:srgbClr val="9AA7B5"/>
+                </a:solidFill>
+                <a:latin typeface="Calibri" pitchFamily="34" charset="0"/>
+                <a:ea typeface="Calibri" pitchFamily="34" charset="-122"/>
+                <a:cs typeface="Calibri" pitchFamily="34" charset="-120"/>
+              </a:rPr>
+              <a:t>"grip beside the mug" becomes the same move every time</a:t>
+            </a:r>
+            <a:endParaRPr lang="en-US" sz="1200" dirty="0"/>
+          </a:p>
+        </p:txBody>
+      </p:sp>
+    </p:spTree>
+  </p:cSld>
+  <p:clrMapOvr>
+    <a:masterClrMapping/>
+  </p:clrMapOvr>
+</p:sld>
+</file>
+
+<file path=ppt/slides/slide7.xml><?xml version="1.0" encoding="utf-8"?>
+<p:sld xmlns:a="http://schemas.openxmlformats.org/drawingml/2006/main" xmlns:r="http://schemas.openxmlformats.org/officeDocument/2006/relationships" xmlns:p="http://schemas.openxmlformats.org/presentationml/2006/main">
+  <p:cSld name="Slide 7">
+    <p:bg>
+      <p:bgPr>
+        <a:solidFill>
+          <a:srgbClr val="161B22"/>
+        </a:solidFill>
+      </p:bgPr>
+    </p:bg>
+    <p:spTree>
+      <p:nvGrpSpPr>
+        <p:cNvPr id="1" name=""/>
+        <p:cNvGrpSpPr/>
+        <p:nvPr/>
+      </p:nvGrpSpPr>
+      <p:grpSpPr>
+        <a:xfrm>
+          <a:off x="0" y="0"/>
+          <a:ext cx="0" cy="0"/>
+          <a:chOff x="0" y="0"/>
+          <a:chExt cx="0" cy="0"/>
+        </a:xfrm>
+      </p:grpSpPr>
+      <p:sp>
+        <p:nvSpPr>
+          <p:cNvPr id="2" name="Text 0"/>
+          <p:cNvSpPr txBox="1"/>
+          <p:nvPr/>
+        </p:nvSpPr>
+        <p:spPr>
+          <a:xfrm>
+            <a:off x="457200" y="274320"/>
+            <a:ext cx="8229600" cy="548640"/>
+          </a:xfrm>
+          <a:prstGeom prst="rect">
+            <a:avLst/>
+          </a:prstGeom>
+          <a:noFill/>
+          <a:ln/>
+        </p:spPr>
+        <p:txBody>
+          <a:bodyPr wrap="square" lIns="0" tIns="0" rIns="0" bIns="0" rtlCol="0" anchor="ctr"/>
+          <a:lstStyle/>
+          <a:p>
+            <a:pPr indent="0" marL="0">
+              <a:buNone/>
+            </a:pPr>
+            <a:r>
+              <a:rPr lang="en-US" sz="3000" b="1" dirty="0">
+                <a:solidFill>
+                  <a:srgbClr val="FFFFFF"/>
+                </a:solidFill>
+                <a:latin typeface="Arial" pitchFamily="34" charset="0"/>
+                <a:ea typeface="Arial" pitchFamily="34" charset="-122"/>
+                <a:cs typeface="Arial" pitchFamily="34" charset="-120"/>
+              </a:rPr>
               <a:t>OpenVINO: faster, same accuracy</a:t>
             </a:r>
             <a:endParaRPr lang="en-US" sz="3000" dirty="0"/>
@@ -4833,9 +5708,9 @@
 </p:sld>
 </file>
 
-<file path=ppt/slides/slide7.xml><?xml version="1.0" encoding="utf-8"?>
+<file path=ppt/slides/slide8.xml><?xml version="1.0" encoding="utf-8"?>
 <p:sld xmlns:a="http://schemas.openxmlformats.org/drawingml/2006/main" xmlns:r="http://schemas.openxmlformats.org/officeDocument/2006/relationships" xmlns:p="http://schemas.openxmlformats.org/presentationml/2006/main">
-  <p:cSld name="Slide 7">
+  <p:cSld name="Slide 8">
     <p:bg>
       <p:bgPr>
         <a:solidFill>

</xml_diff>

<commit_message>
Voice tested with Speechmatics: spoken command sets the table; restore voice claims
Co-Authored-By: Claude Opus 5 <noreply@anthropic.com>
</commit_message>
<xml_diff>
--- a/submission/slides.pptx
+++ b/submission/slides.pptx
@@ -2280,7 +2280,7 @@
                 <a:ea typeface="Calibri" pitchFamily="34" charset="-122"/>
                 <a:cs typeface="Calibri" pitchFamily="34" charset="-120"/>
               </a:rPr>
-              <a:t>Type what you want</a:t>
+              <a:t>Say or type what you want</a:t>
             </a:r>
             <a:endParaRPr lang="en-US" sz="1600" dirty="0"/>
           </a:p>
@@ -3047,7 +3047,7 @@
                 <a:ea typeface="Calibri" pitchFamily="34" charset="-122"/>
                 <a:cs typeface="Calibri" pitchFamily="34" charset="-120"/>
               </a:rPr>
-              <a:t>Plain-language instructions. No programming, no app, no fixed commands.</a:t>
+              <a:t>Plain language, spoken or typed. No programming, no app, no fixed commands.</a:t>
             </a:r>
             <a:endParaRPr lang="en-US" sz="1300" dirty="0"/>
           </a:p>

</xml_diff>

<commit_message>
Slides: fix a stale figure and a mixed-precision claim
Audited every number in the deck against bench/results.json before submitting.

Two were wrong:
- Slide 2 still said "~4 s to understand a command", the old i7-1165G7 figure.
  On the Core Ultra it is 1.3 s on the Arc iGPU, which slide 6 already said --
  the deck contradicted itself. Now 1.3 s.
- Slide 6 paired "0.90 ms" with "10/10 mugs placed". The 0.90 ms is FP32 on the
  NPU; the 10/10 is FP16 (1.06 ms). Two rows presented as one result. Both the
  slide and the spoken note now say which precision each belongs to, and the
  README row is tightened the same way.

Everything else checked out exactly: all six benchmark bars match the measured
values to the millisecond, and 30/30, 29/30, 95%, 1,219 demos, 0.5 mm camera
error, the 1.5 mm hand-off margin, the 6 cm bump and 1.3 s / 2.8x on the iGPU
are all correct. slides.pptx and slides.pdf rebuilt.

Co-Authored-By: Claude Opus 5 <noreply@anthropic.com>
</commit_message>
<xml_diff>
--- a/submission/slides.pptx
+++ b/submission/slides.pptx
@@ -1619,7 +1619,7 @@
           <a:p>
             <a:r>
               <a:rPr lang="en-US" dirty="0"/>
-              <a:t>We measured this on a Core Ultra 7 155H, across all three of its Intel chips. OpenVINO makes our trained policy nearly three times faster on the CPU, and the robot still succeeds just as often. The same policy runs on the AI Boost NPU at nine tenths of a millisecond, placing the mug ten times out of ten, which frees the processor and graphics for everything else. The Arc graphics reads a command in one point three seconds, almost three times faster than the processor. One honest finding: the NPU compiler cannot build the vision-language model at all, so that part falls back to the graphics chip automatically.</a:t>
+              <a:t>We measured this on a Core Ultra 7 155H, across all three of its Intel chips. OpenVINO makes our trained policy nearly three times faster on the CPU, and the robot still succeeds just as often. The same policy runs on the AI Boost NPU at nine tenths of a millisecond, and at half precision there it places the mug ten times out of ten, which frees the processor and graphics for everything else. The Arc graphics reads a command in one point three seconds, almost three times faster than the processor. One honest finding: the NPU compiler cannot build the vision-language model at all, so that part falls back to the graphics chip automatically.</a:t>
             </a:r>
             <a:endParaRPr lang="en-US" dirty="0"/>
           </a:p>
@@ -2735,7 +2735,7 @@
                 <a:ea typeface="Arial" pitchFamily="34" charset="-122"/>
                 <a:cs typeface="Arial" pitchFamily="34" charset="-120"/>
               </a:rPr>
-              <a:t>~4 s</a:t>
+              <a:t>1.3 s</a:t>
             </a:r>
             <a:endParaRPr lang="en-US" sz="3600" dirty="0"/>
           </a:p>
@@ -5622,7 +5622,7 @@
                 <a:ea typeface="Calibri" pitchFamily="34" charset="-122"/>
                 <a:cs typeface="Calibri" pitchFamily="34" charset="-120"/>
               </a:rPr>
-              <a:t>on the AI Boost NPU — 10/10 mugs placed, freeing the CPU and iGPU</a:t>
+              <a:t>for the whole policy on the AI Boost NPU at FP32; at FP16 it places 10/10 mugs</a:t>
             </a:r>
             <a:endParaRPr lang="en-US" sz="1200" dirty="0"/>
           </a:p>

</xml_diff>